<commit_message>
minor fixes to report and presentation
</commit_message>
<xml_diff>
--- a/Hackathon Presentation.pptx
+++ b/Hackathon Presentation.pptx
@@ -114,7 +114,7 @@
   </p:defaultTextStyle>
   <p:extLst>
     <p:ext uri="{EFAFB233-063F-42B5-8137-9DF3F51BA10A}">
-      <p15:sldGuideLst xmlns:p15="http://schemas.microsoft.com/office/powerpoint/2012/main">
+      <p15:sldGuideLst xmlns:p15="http://schemas.microsoft.com/office/powerpoint/2012/main" xmlns="">
         <p15:guide id="1" orient="horz" pos="2160">
           <p15:clr>
             <a:srgbClr val="A4A3A4"/>
@@ -311,7 +311,7 @@
             <a:fld id="{1D8BD707-D9CF-40AE-B4C6-C98DA3205C09}" type="datetimeFigureOut">
               <a:rPr lang="en-US" smtClean="0"/>
               <a:pPr/>
-              <a:t>3/3/26</a:t>
+              <a:t>3/4/2026</a:t>
             </a:fld>
             <a:endParaRPr lang="en-US"/>
           </a:p>
@@ -476,7 +476,7 @@
             <a:fld id="{1D8BD707-D9CF-40AE-B4C6-C98DA3205C09}" type="datetimeFigureOut">
               <a:rPr lang="en-US" smtClean="0"/>
               <a:pPr/>
-              <a:t>3/3/26</a:t>
+              <a:t>3/4/2026</a:t>
             </a:fld>
             <a:endParaRPr lang="en-US"/>
           </a:p>
@@ -651,7 +651,7 @@
             <a:fld id="{1D8BD707-D9CF-40AE-B4C6-C98DA3205C09}" type="datetimeFigureOut">
               <a:rPr lang="en-US" smtClean="0"/>
               <a:pPr/>
-              <a:t>3/3/26</a:t>
+              <a:t>3/4/2026</a:t>
             </a:fld>
             <a:endParaRPr lang="en-US"/>
           </a:p>
@@ -816,7 +816,7 @@
             <a:fld id="{1D8BD707-D9CF-40AE-B4C6-C98DA3205C09}" type="datetimeFigureOut">
               <a:rPr lang="en-US" smtClean="0"/>
               <a:pPr/>
-              <a:t>3/3/26</a:t>
+              <a:t>3/4/2026</a:t>
             </a:fld>
             <a:endParaRPr lang="en-US"/>
           </a:p>
@@ -1058,7 +1058,7 @@
             <a:fld id="{1D8BD707-D9CF-40AE-B4C6-C98DA3205C09}" type="datetimeFigureOut">
               <a:rPr lang="en-US" smtClean="0"/>
               <a:pPr/>
-              <a:t>3/3/26</a:t>
+              <a:t>3/4/2026</a:t>
             </a:fld>
             <a:endParaRPr lang="en-US"/>
           </a:p>
@@ -1340,7 +1340,7 @@
             <a:fld id="{1D8BD707-D9CF-40AE-B4C6-C98DA3205C09}" type="datetimeFigureOut">
               <a:rPr lang="en-US" smtClean="0"/>
               <a:pPr/>
-              <a:t>3/3/26</a:t>
+              <a:t>3/4/2026</a:t>
             </a:fld>
             <a:endParaRPr lang="en-US"/>
           </a:p>
@@ -1756,7 +1756,7 @@
             <a:fld id="{1D8BD707-D9CF-40AE-B4C6-C98DA3205C09}" type="datetimeFigureOut">
               <a:rPr lang="en-US" smtClean="0"/>
               <a:pPr/>
-              <a:t>3/3/26</a:t>
+              <a:t>3/4/2026</a:t>
             </a:fld>
             <a:endParaRPr lang="en-US"/>
           </a:p>
@@ -1870,7 +1870,7 @@
             <a:fld id="{1D8BD707-D9CF-40AE-B4C6-C98DA3205C09}" type="datetimeFigureOut">
               <a:rPr lang="en-US" smtClean="0"/>
               <a:pPr/>
-              <a:t>3/3/26</a:t>
+              <a:t>3/4/2026</a:t>
             </a:fld>
             <a:endParaRPr lang="en-US"/>
           </a:p>
@@ -1962,7 +1962,7 @@
             <a:fld id="{1D8BD707-D9CF-40AE-B4C6-C98DA3205C09}" type="datetimeFigureOut">
               <a:rPr lang="en-US" smtClean="0"/>
               <a:pPr/>
-              <a:t>3/3/26</a:t>
+              <a:t>3/4/2026</a:t>
             </a:fld>
             <a:endParaRPr lang="en-US"/>
           </a:p>
@@ -2234,7 +2234,7 @@
             <a:fld id="{1D8BD707-D9CF-40AE-B4C6-C98DA3205C09}" type="datetimeFigureOut">
               <a:rPr lang="en-US" smtClean="0"/>
               <a:pPr/>
-              <a:t>3/3/26</a:t>
+              <a:t>3/4/2026</a:t>
             </a:fld>
             <a:endParaRPr lang="en-US"/>
           </a:p>
@@ -2483,7 +2483,7 @@
             <a:fld id="{1D8BD707-D9CF-40AE-B4C6-C98DA3205C09}" type="datetimeFigureOut">
               <a:rPr lang="en-US" smtClean="0"/>
               <a:pPr/>
-              <a:t>3/3/26</a:t>
+              <a:t>3/4/2026</a:t>
             </a:fld>
             <a:endParaRPr lang="en-US"/>
           </a:p>
@@ -2691,7 +2691,7 @@
             <a:fld id="{1D8BD707-D9CF-40AE-B4C6-C98DA3205C09}" type="datetimeFigureOut">
               <a:rPr lang="en-US" smtClean="0"/>
               <a:pPr/>
-              <a:t>3/3/26</a:t>
+              <a:t>3/4/2026</a:t>
             </a:fld>
             <a:endParaRPr lang="en-US"/>
           </a:p>
@@ -3074,7 +3074,7 @@
         </p:nvSpPr>
         <p:spPr>
           <a:xfrm>
-            <a:off x="685800" y="1295400"/>
+            <a:off x="685800" y="3200400"/>
             <a:ext cx="7772400" cy="1470025"/>
           </a:xfrm>
         </p:spPr>
@@ -3086,11 +3086,12 @@
           <a:p>
             <a:r>
               <a:rPr lang="en-US" sz="2400" b="1" dirty="0"/>
-              <a:t>“ResNet-18 and DenseNet-121 Architectures for OCT Retinal Analysis: Effects of Transfer Learning, Data Augmentation, Fine-Tuning Strategies and Model Calibration”</a:t>
-            </a:r>
-            <a:br>
-              <a:rPr lang="el-GR" sz="2400" dirty="0"/>
-            </a:br>
+              <a:t>“ResNet-18 and DenseNet-121 Architectures for OCT Retinal Analysis: Effects of Transfer Learning, Data Augmentation, Fine-Tuning Strategies and Model Calibration</a:t>
+            </a:r>
+            <a:r>
+              <a:rPr lang="en-US" sz="2400" b="1" dirty="0" smtClean="0"/>
+              <a:t>”</a:t>
+            </a:r>
             <a:endParaRPr lang="el-GR" sz="2400" dirty="0"/>
           </a:p>
         </p:txBody>
@@ -3107,7 +3108,7 @@
         </p:nvSpPr>
         <p:spPr>
           <a:xfrm>
-            <a:off x="1295400" y="3200400"/>
+            <a:off x="1295400" y="4953000"/>
             <a:ext cx="6400800" cy="1676400"/>
           </a:xfrm>
         </p:spPr>
@@ -3210,6 +3211,47 @@
           </a:p>
         </p:txBody>
       </p:sp>
+      <p:pic>
+        <p:nvPicPr>
+          <p:cNvPr id="2052" name="Picture 4" descr="C:\Users\PC\Downloads\deep_learning_top.png"/>
+          <p:cNvPicPr>
+            <a:picLocks noChangeAspect="1" noChangeArrowheads="1"/>
+          </p:cNvPicPr>
+          <p:nvPr/>
+        </p:nvPicPr>
+        <p:blipFill>
+          <a:blip r:embed="rId2">
+            <a:extLst>
+              <a:ext uri="{28A0092B-C50C-407E-A947-70E740481C1C}">
+                <a14:useLocalDpi xmlns:a14="http://schemas.microsoft.com/office/drawing/2010/main" val="0"/>
+              </a:ext>
+            </a:extLst>
+          </a:blip>
+          <a:srcRect/>
+          <a:stretch>
+            <a:fillRect/>
+          </a:stretch>
+        </p:blipFill>
+        <p:spPr bwMode="auto">
+          <a:xfrm>
+            <a:off x="0" y="0"/>
+            <a:ext cx="9144000" cy="3048000"/>
+          </a:xfrm>
+          <a:prstGeom prst="rect">
+            <a:avLst/>
+          </a:prstGeom>
+          <a:noFill/>
+          <a:extLst>
+            <a:ext uri="{909E8E84-426E-40DD-AFC4-6F175D3DCCD1}">
+              <a14:hiddenFill xmlns:a14="http://schemas.microsoft.com/office/drawing/2010/main">
+                <a:solidFill>
+                  <a:srgbClr val="FFFFFF"/>
+                </a:solidFill>
+              </a14:hiddenFill>
+            </a:ext>
+          </a:extLst>
+        </p:spPr>
+      </p:pic>
     </p:spTree>
     <p:extLst>
       <p:ext uri="{BB962C8B-B14F-4D97-AF65-F5344CB8AC3E}">
@@ -3379,7 +3421,19 @@
                     <a:ea typeface="Calibri"/>
                     <a:cs typeface="Arial"/>
                   </a:rPr>
-                  <a:t> Neovascularization, (b) Diabetic Macular Edema, (d) </a:t>
+                  <a:t> Neovascularization, (b) Diabetic Macular Edema, </a:t>
+                </a:r>
+                <a:r>
+                  <a:rPr lang="en-US" sz="1000" i="1" dirty="0" smtClean="0">
+                    <a:solidFill>
+                      <a:srgbClr val="0070C0"/>
+                    </a:solidFill>
+                    <a:effectLst/>
+                    <a:latin typeface="Calibri"/>
+                    <a:ea typeface="Calibri"/>
+                    <a:cs typeface="Arial"/>
+                  </a:rPr>
+                  <a:t>(c) </a:t>
                 </a:r>
                 <a:r>
                   <a:rPr lang="en-US" sz="1000" i="1" dirty="0" err="1">
@@ -3470,6 +3524,15 @@
               <p:blipFill>
                 <a:blip r:embed="rId2">
                   <a:extLst>
+                    <a:ext uri="{BEBA8EAE-BF5A-486C-A8C5-ECC9F3942E4B}">
+                      <a14:imgProps xmlns:a14="http://schemas.microsoft.com/office/drawing/2010/main">
+                        <a14:imgLayer r:embed="rId3">
+                          <a14:imgEffect>
+                            <a14:brightnessContrast bright="20000"/>
+                          </a14:imgEffect>
+                        </a14:imgLayer>
+                      </a14:imgProps>
+                    </a:ext>
                     <a:ext uri="{28A0092B-C50C-407E-A947-70E740481C1C}">
                       <a14:useLocalDpi xmlns:a14="http://schemas.microsoft.com/office/drawing/2010/main" val="0"/>
                     </a:ext>
@@ -3972,7 +4035,7 @@
         <p:spPr>
           <a:xfrm>
             <a:off x="152400" y="685800"/>
-            <a:ext cx="6045629" cy="2354491"/>
+            <a:ext cx="6164252" cy="2446824"/>
           </a:xfrm>
           <a:prstGeom prst="rect">
             <a:avLst/>
@@ -3990,17 +4053,22 @@
               </a:spcAft>
             </a:pPr>
             <a:r>
-              <a:rPr lang="en-US" sz="1200" b="1" dirty="0"/>
+              <a:rPr lang="en-US" sz="1400" b="1" dirty="0"/>
               <a:t>CNV – </a:t>
             </a:r>
             <a:r>
-              <a:rPr lang="en-US" sz="1200" b="1" dirty="0" err="1"/>
+              <a:rPr lang="en-US" sz="1400" b="1" dirty="0" err="1"/>
               <a:t>Choroidal</a:t>
             </a:r>
             <a:r>
-              <a:rPr lang="en-US" sz="1200" b="1" dirty="0"/>
-              <a:t> Neovascularization </a:t>
-            </a:r>
+              <a:rPr lang="en-US" sz="1400" b="1" dirty="0"/>
+              <a:t> Neovascularization  </a:t>
+            </a:r>
+            <a:r>
+              <a:rPr lang="en-US" sz="1200" dirty="0" smtClean="0"/>
+              <a:t>(Figure 1a)</a:t>
+            </a:r>
+            <a:endParaRPr lang="en-US" sz="1200" dirty="0"/>
           </a:p>
           <a:p>
             <a:r>
@@ -4018,7 +4086,7 @@
               <a:t>  </a:t>
             </a:r>
             <a:r>
-              <a:rPr lang="en-US" sz="1200" dirty="0" err="1">
+              <a:rPr lang="en-US" sz="1200" b="1" dirty="0" err="1">
                 <a:solidFill>
                   <a:srgbClr val="C00000"/>
                 </a:solidFill>
@@ -4026,7 +4094,7 @@
               <a:t>Subretinal</a:t>
             </a:r>
             <a:r>
-              <a:rPr lang="en-US" sz="1200" dirty="0">
+              <a:rPr lang="en-US" sz="1200" b="1" dirty="0">
                 <a:solidFill>
                   <a:srgbClr val="C00000"/>
                 </a:solidFill>
@@ -4038,7 +4106,7 @@
               <a:t>,  </a:t>
             </a:r>
             <a:r>
-              <a:rPr lang="en-US" sz="1200" dirty="0" err="1">
+              <a:rPr lang="en-US" sz="1200" b="1" dirty="0" err="1">
                 <a:solidFill>
                   <a:srgbClr val="C00000"/>
                 </a:solidFill>
@@ -4046,7 +4114,7 @@
               <a:t>Hyperreflective</a:t>
             </a:r>
             <a:r>
-              <a:rPr lang="en-US" sz="1200" dirty="0">
+              <a:rPr lang="en-US" sz="1200" b="1" dirty="0">
                 <a:solidFill>
                   <a:srgbClr val="C00000"/>
                 </a:solidFill>
@@ -4058,7 +4126,7 @@
               <a:t>, </a:t>
             </a:r>
             <a:r>
-              <a:rPr lang="en-US" sz="1200" dirty="0">
+              <a:rPr lang="en-US" sz="1200" b="1" dirty="0">
                 <a:solidFill>
                   <a:srgbClr val="C00000"/>
                 </a:solidFill>
@@ -4076,9 +4144,26 @@
               </a:spcAft>
             </a:pPr>
             <a:r>
-              <a:rPr lang="en-US" sz="1200" b="1" dirty="0"/>
-              <a:t>DME – Diabetic Macular Edema</a:t>
-            </a:r>
+              <a:rPr lang="en-US" sz="1400" b="1" dirty="0"/>
+              <a:t>DME – Diabetic Macular </a:t>
+            </a:r>
+            <a:r>
+              <a:rPr lang="en-US" sz="1400" b="1" dirty="0" smtClean="0"/>
+              <a:t>Edema  </a:t>
+            </a:r>
+            <a:r>
+              <a:rPr lang="en-US" sz="1200" dirty="0" smtClean="0"/>
+              <a:t>(</a:t>
+            </a:r>
+            <a:r>
+              <a:rPr lang="en-US" sz="1200" dirty="0"/>
+              <a:t>Figure </a:t>
+            </a:r>
+            <a:r>
+              <a:rPr lang="en-US" sz="1200" dirty="0" smtClean="0"/>
+              <a:t>1b)</a:t>
+            </a:r>
+            <a:endParaRPr lang="en-US" sz="1200" b="1" dirty="0"/>
           </a:p>
           <a:p>
             <a:r>
@@ -4096,7 +4181,7 @@
               <a:t>  </a:t>
             </a:r>
             <a:r>
-              <a:rPr lang="en-US" sz="1200" dirty="0" err="1">
+              <a:rPr lang="en-US" sz="1200" b="1" dirty="0" err="1">
                 <a:solidFill>
                   <a:srgbClr val="C00000"/>
                 </a:solidFill>
@@ -4104,7 +4189,7 @@
               <a:t>Intraretinal</a:t>
             </a:r>
             <a:r>
-              <a:rPr lang="en-US" sz="1200" dirty="0">
+              <a:rPr lang="en-US" sz="1200" b="1" dirty="0">
                 <a:solidFill>
                   <a:srgbClr val="C00000"/>
                 </a:solidFill>
@@ -4113,10 +4198,14 @@
             </a:r>
             <a:r>
               <a:rPr lang="en-US" sz="1200" dirty="0"/>
-              <a:t>,  </a:t>
-            </a:r>
-            <a:r>
-              <a:rPr lang="en-US" sz="1200" dirty="0">
+              <a:t>, </a:t>
+            </a:r>
+            <a:r>
+              <a:rPr lang="en-US" sz="1200" b="1" dirty="0"/>
+              <a:t> </a:t>
+            </a:r>
+            <a:r>
+              <a:rPr lang="en-US" sz="1200" b="1" dirty="0">
                 <a:solidFill>
                   <a:srgbClr val="C00000"/>
                 </a:solidFill>
@@ -4124,11 +4213,11 @@
               <a:t>Retinal thickening</a:t>
             </a:r>
             <a:r>
-              <a:rPr lang="en-US" sz="1200" dirty="0"/>
+              <a:rPr lang="en-US" sz="1200" b="1" dirty="0"/>
               <a:t>,  </a:t>
             </a:r>
             <a:r>
-              <a:rPr lang="en-US" sz="1200" dirty="0">
+              <a:rPr lang="en-US" sz="1200" b="1" dirty="0">
                 <a:solidFill>
                   <a:srgbClr val="C00000"/>
                 </a:solidFill>
@@ -4146,8 +4235,20 @@
               </a:spcAft>
             </a:pPr>
             <a:r>
-              <a:rPr lang="en-US" sz="1200" b="1" dirty="0" err="1"/>
+              <a:rPr lang="en-US" sz="1400" b="1" dirty="0" err="1" smtClean="0"/>
               <a:t>Drusen</a:t>
+            </a:r>
+            <a:r>
+              <a:rPr lang="en-US" sz="1400" b="1" dirty="0" smtClean="0"/>
+              <a:t>  </a:t>
+            </a:r>
+            <a:r>
+              <a:rPr lang="en-US" sz="1200" dirty="0"/>
+              <a:t>(Figure </a:t>
+            </a:r>
+            <a:r>
+              <a:rPr lang="en-US" sz="1200" dirty="0" smtClean="0"/>
+              <a:t>1c)</a:t>
             </a:r>
             <a:endParaRPr lang="en-US" sz="1200" b="1" dirty="0"/>
           </a:p>
@@ -4167,7 +4268,7 @@
               <a:t>  </a:t>
             </a:r>
             <a:r>
-              <a:rPr lang="en-US" sz="1200" dirty="0">
+              <a:rPr lang="en-US" sz="1200" b="1" dirty="0">
                 <a:solidFill>
                   <a:srgbClr val="C00000"/>
                 </a:solidFill>
@@ -4175,11 +4276,11 @@
               <a:t>Dome-shaped elevations under RPE</a:t>
             </a:r>
             <a:r>
-              <a:rPr lang="en-US" sz="1200" dirty="0"/>
+              <a:rPr lang="en-US" sz="1200" b="1" dirty="0"/>
               <a:t>,  </a:t>
             </a:r>
             <a:r>
-              <a:rPr lang="en-US" sz="1200" dirty="0">
+              <a:rPr lang="en-US" sz="1200" b="1" dirty="0">
                 <a:solidFill>
                   <a:srgbClr val="C00000"/>
                 </a:solidFill>
@@ -4198,7 +4299,7 @@
         <p:spPr>
           <a:xfrm>
             <a:off x="6286500" y="838200"/>
-            <a:ext cx="2307938" cy="1569660"/>
+            <a:ext cx="2307938" cy="1692771"/>
           </a:xfrm>
           <a:prstGeom prst="rect">
             <a:avLst/>
@@ -4222,7 +4323,7 @@
           </a:p>
           <a:p>
             <a:r>
-              <a:rPr lang="en-US" sz="1200" b="1" dirty="0" err="1">
+              <a:rPr lang="en-US" sz="1400" b="1" dirty="0" err="1">
                 <a:solidFill>
                   <a:srgbClr val="0070C0"/>
                 </a:solidFill>
@@ -4230,7 +4331,7 @@
               <a:t>Kermany</a:t>
             </a:r>
             <a:r>
-              <a:rPr lang="en-US" sz="1200" b="1" dirty="0">
+              <a:rPr lang="en-US" sz="1400" b="1" dirty="0">
                 <a:solidFill>
                   <a:srgbClr val="0070C0"/>
                 </a:solidFill>
@@ -4258,7 +4359,7 @@
           </a:p>
           <a:p>
             <a:r>
-              <a:rPr lang="en-US" sz="1200" b="1" dirty="0">
+              <a:rPr lang="en-US" sz="1400" b="1" dirty="0">
                 <a:solidFill>
                   <a:srgbClr val="7030A0"/>
                 </a:solidFill>
@@ -4268,7 +4369,7 @@
           </a:p>
           <a:p>
             <a:r>
-              <a:rPr lang="en-US" sz="1200" b="1" dirty="0">
+              <a:rPr lang="en-US" sz="1400" b="1" dirty="0">
                 <a:solidFill>
                   <a:srgbClr val="7030A0"/>
                 </a:solidFill>
@@ -4278,14 +4379,14 @@
           </a:p>
           <a:p>
             <a:r>
-              <a:rPr lang="en-US" sz="1200" b="1" dirty="0">
+              <a:rPr lang="en-US" sz="1400" b="1" dirty="0">
                 <a:solidFill>
                   <a:srgbClr val="7030A0"/>
                 </a:solidFill>
               </a:rPr>
               <a:t>Test set 20%</a:t>
             </a:r>
-            <a:endParaRPr lang="el-GR" sz="1200" b="1" dirty="0">
+            <a:endParaRPr lang="el-GR" sz="1400" b="1" dirty="0">
               <a:solidFill>
                 <a:srgbClr val="7030A0"/>
               </a:solidFill>
@@ -4302,7 +4403,7 @@
         <p:spPr>
           <a:xfrm>
             <a:off x="202037" y="3349749"/>
-            <a:ext cx="3455563" cy="969496"/>
+            <a:ext cx="3455563" cy="984885"/>
           </a:xfrm>
           <a:prstGeom prst="rect">
             <a:avLst/>
@@ -4320,11 +4421,11 @@
               </a:spcAft>
             </a:pPr>
             <a:r>
-              <a:rPr lang="en-US" sz="1300" b="1" dirty="0"/>
+              <a:rPr lang="en-US" sz="1400" b="1" dirty="0"/>
               <a:t>Optical Coherence Tomography </a:t>
             </a:r>
             <a:r>
-              <a:rPr lang="en-US" sz="1300" dirty="0"/>
+              <a:rPr lang="en-US" sz="1400" dirty="0"/>
               <a:t>(OCT) </a:t>
             </a:r>
           </a:p>
@@ -4354,7 +4455,7 @@
         <p:spPr>
           <a:xfrm>
             <a:off x="4419600" y="3352800"/>
-            <a:ext cx="3733800" cy="1292662"/>
+            <a:ext cx="3733800" cy="1308050"/>
           </a:xfrm>
           <a:prstGeom prst="rect">
             <a:avLst/>
@@ -4368,7 +4469,7 @@
           <a:p>
             <a:pPr algn="just"/>
             <a:r>
-              <a:rPr lang="en-US" sz="1300" b="1" dirty="0"/>
+              <a:rPr lang="en-US" sz="1400" b="1" dirty="0"/>
               <a:t>OCT scan reveals: </a:t>
             </a:r>
           </a:p>
@@ -4975,14 +5076,14 @@
           <p:nvPr>
             <p:extLst>
               <p:ext uri="{D42A27DB-BD31-4B8C-83A1-F6EECF244321}">
-                <p14:modId xmlns:p14="http://schemas.microsoft.com/office/powerpoint/2010/main" val="63940150"/>
+                <p14:modId xmlns:p14="http://schemas.microsoft.com/office/powerpoint/2010/main" val="2575205338"/>
               </p:ext>
             </p:extLst>
           </p:nvPr>
         </p:nvGraphicFramePr>
         <p:xfrm>
-          <a:off x="4636608" y="4145280"/>
-          <a:ext cx="4274820" cy="883920"/>
+          <a:off x="4636608" y="4038600"/>
+          <a:ext cx="4274820" cy="1371600"/>
         </p:xfrm>
         <a:graphic>
           <a:graphicData uri="http://schemas.openxmlformats.org/drawingml/2006/table">
@@ -4994,21 +5095,21 @@
                 <a:gridCol w="1424940">
                   <a:extLst>
                     <a:ext uri="{9D8B030D-6E8A-4147-A177-3AD203B41FA5}">
-                      <a16:colId xmlns:a16="http://schemas.microsoft.com/office/drawing/2014/main" val="20000"/>
+                      <a16:colId xmlns:a16="http://schemas.microsoft.com/office/drawing/2014/main" xmlns="" val="20000"/>
                     </a:ext>
                   </a:extLst>
                 </a:gridCol>
                 <a:gridCol w="1424940">
                   <a:extLst>
                     <a:ext uri="{9D8B030D-6E8A-4147-A177-3AD203B41FA5}">
-                      <a16:colId xmlns:a16="http://schemas.microsoft.com/office/drawing/2014/main" val="20001"/>
+                      <a16:colId xmlns:a16="http://schemas.microsoft.com/office/drawing/2014/main" xmlns="" val="20001"/>
                     </a:ext>
                   </a:extLst>
                 </a:gridCol>
                 <a:gridCol w="1424940">
                   <a:extLst>
                     <a:ext uri="{9D8B030D-6E8A-4147-A177-3AD203B41FA5}">
-                      <a16:colId xmlns:a16="http://schemas.microsoft.com/office/drawing/2014/main" val="20002"/>
+                      <a16:colId xmlns:a16="http://schemas.microsoft.com/office/drawing/2014/main" xmlns="" val="20002"/>
                     </a:ext>
                   </a:extLst>
                 </a:gridCol>
@@ -5034,8 +5135,8 @@
                     <a:lstStyle/>
                     <a:p>
                       <a:r>
-                        <a:rPr lang="en-US" sz="1200" dirty="0"/>
-                        <a:t>DenseNet-121</a:t>
+                        <a:rPr lang="en-US" sz="1200" dirty="0" smtClean="0"/>
+                        <a:t>ResNet-18</a:t>
                       </a:r>
                       <a:endParaRPr lang="el-GR" sz="1200" dirty="0"/>
                     </a:p>
@@ -5047,10 +5148,30 @@
                     <a:bodyPr/>
                     <a:lstStyle/>
                     <a:p>
+                      <a:pPr marL="0" marR="0" indent="0" algn="l" defTabSz="914400" rtl="0" eaLnBrk="1" fontAlgn="auto" latinLnBrk="0" hangingPunct="1">
+                        <a:lnSpc>
+                          <a:spcPct val="100000"/>
+                        </a:lnSpc>
+                        <a:spcBef>
+                          <a:spcPts val="0"/>
+                        </a:spcBef>
+                        <a:spcAft>
+                          <a:spcPts val="0"/>
+                        </a:spcAft>
+                        <a:buClrTx/>
+                        <a:buSzTx/>
+                        <a:buFontTx/>
+                        <a:buNone/>
+                        <a:tabLst/>
+                        <a:defRPr/>
+                      </a:pPr>
                       <a:r>
-                        <a:rPr lang="en-US" sz="1200" dirty="0"/>
-                        <a:t>ResNet-18</a:t>
+                        <a:rPr lang="en-US" sz="1200" dirty="0" smtClean="0"/>
+                        <a:t>DenseNet-121</a:t>
                       </a:r>
+                      <a:endParaRPr lang="el-GR" sz="1200" dirty="0" smtClean="0"/>
+                    </a:p>
+                    <a:p>
                       <a:endParaRPr lang="el-GR" sz="1200" dirty="0"/>
                     </a:p>
                   </a:txBody>
@@ -5058,7 +5179,7 @@
                 </a:tc>
                 <a:extLst>
                   <a:ext uri="{0D108BD9-81ED-4DB2-BD59-A6C34878D82A}">
-                    <a16:rowId xmlns:a16="http://schemas.microsoft.com/office/drawing/2014/main" val="10000"/>
+                    <a16:rowId xmlns:a16="http://schemas.microsoft.com/office/drawing/2014/main" xmlns="" val="10000"/>
                   </a:ext>
                 </a:extLst>
               </a:tr>
@@ -5069,8 +5190,22 @@
                     <a:lstStyle/>
                     <a:p>
                       <a:r>
-                        <a:rPr lang="en-US" sz="1200" dirty="0"/>
+                        <a:rPr lang="en-US" sz="1200" b="1" dirty="0"/>
                         <a:t>Connections</a:t>
+                      </a:r>
+                      <a:endParaRPr lang="el-GR" sz="1200" b="1" dirty="0"/>
+                    </a:p>
+                  </a:txBody>
+                  <a:tcPr/>
+                </a:tc>
+                <a:tc>
+                  <a:txBody>
+                    <a:bodyPr/>
+                    <a:lstStyle/>
+                    <a:p>
+                      <a:r>
+                        <a:rPr lang="en-US" sz="1200" dirty="0" smtClean="0"/>
+                        <a:t>Addition</a:t>
                       </a:r>
                       <a:endParaRPr lang="el-GR" sz="1200" dirty="0"/>
                     </a:p>
@@ -5082,11 +5217,52 @@
                     <a:bodyPr/>
                     <a:lstStyle/>
                     <a:p>
+                      <a:pPr marL="0" marR="0" indent="0" algn="l" defTabSz="914400" rtl="0" eaLnBrk="1" fontAlgn="auto" latinLnBrk="0" hangingPunct="1">
+                        <a:lnSpc>
+                          <a:spcPct val="100000"/>
+                        </a:lnSpc>
+                        <a:spcBef>
+                          <a:spcPts val="0"/>
+                        </a:spcBef>
+                        <a:spcAft>
+                          <a:spcPts val="0"/>
+                        </a:spcAft>
+                        <a:buClrTx/>
+                        <a:buSzTx/>
+                        <a:buFontTx/>
+                        <a:buNone/>
+                        <a:tabLst/>
+                        <a:defRPr/>
+                      </a:pPr>
                       <a:r>
-                        <a:rPr lang="en-US" sz="1200" dirty="0"/>
+                        <a:rPr lang="en-US" sz="1200" dirty="0" smtClean="0"/>
                         <a:t>Concatenation</a:t>
                       </a:r>
+                      <a:endParaRPr lang="el-GR" sz="1200" dirty="0" smtClean="0"/>
+                    </a:p>
+                    <a:p>
                       <a:endParaRPr lang="el-GR" sz="1200" dirty="0"/>
+                    </a:p>
+                  </a:txBody>
+                  <a:tcPr/>
+                </a:tc>
+                <a:extLst>
+                  <a:ext uri="{0D108BD9-81ED-4DB2-BD59-A6C34878D82A}">
+                    <a16:rowId xmlns:a16="http://schemas.microsoft.com/office/drawing/2014/main" xmlns="" val="10001"/>
+                  </a:ext>
+                </a:extLst>
+              </a:tr>
+              <a:tr h="294640">
+                <a:tc>
+                  <a:txBody>
+                    <a:bodyPr/>
+                    <a:lstStyle/>
+                    <a:p>
+                      <a:r>
+                        <a:rPr lang="en-US" sz="1200" b="1" dirty="0"/>
+                        <a:t>Memory Usage</a:t>
+                      </a:r>
+                      <a:endParaRPr lang="el-GR" sz="1200" b="1" dirty="0"/>
                     </a:p>
                   </a:txBody>
                   <a:tcPr/>
@@ -5097,43 +5273,8 @@
                     <a:lstStyle/>
                     <a:p>
                       <a:r>
-                        <a:rPr lang="en-US" sz="1200" dirty="0"/>
-                        <a:t>Addition</a:t>
-                      </a:r>
-                      <a:endParaRPr lang="el-GR" sz="1200" dirty="0"/>
-                    </a:p>
-                  </a:txBody>
-                  <a:tcPr/>
-                </a:tc>
-                <a:extLst>
-                  <a:ext uri="{0D108BD9-81ED-4DB2-BD59-A6C34878D82A}">
-                    <a16:rowId xmlns:a16="http://schemas.microsoft.com/office/drawing/2014/main" val="10001"/>
-                  </a:ext>
-                </a:extLst>
-              </a:tr>
-              <a:tr h="294640">
-                <a:tc>
-                  <a:txBody>
-                    <a:bodyPr/>
-                    <a:lstStyle/>
-                    <a:p>
-                      <a:r>
-                        <a:rPr lang="en-US" sz="1200" dirty="0"/>
-                        <a:t>Memory Usage</a:t>
-                      </a:r>
-                      <a:endParaRPr lang="el-GR" sz="1200" dirty="0"/>
-                    </a:p>
-                  </a:txBody>
-                  <a:tcPr/>
-                </a:tc>
-                <a:tc>
-                  <a:txBody>
-                    <a:bodyPr/>
-                    <a:lstStyle/>
-                    <a:p>
-                      <a:r>
-                        <a:rPr lang="en-US" sz="1200" dirty="0"/>
-                        <a:t>Higher</a:t>
+                        <a:rPr lang="en-US" sz="1200" dirty="0" smtClean="0"/>
+                        <a:t>Lower</a:t>
                       </a:r>
                       <a:endParaRPr lang="el-GR" sz="1200" dirty="0"/>
                     </a:p>
@@ -5145,10 +5286,30 @@
                     <a:bodyPr/>
                     <a:lstStyle/>
                     <a:p>
+                      <a:pPr marL="0" marR="0" indent="0" algn="l" defTabSz="914400" rtl="0" eaLnBrk="1" fontAlgn="auto" latinLnBrk="0" hangingPunct="1">
+                        <a:lnSpc>
+                          <a:spcPct val="100000"/>
+                        </a:lnSpc>
+                        <a:spcBef>
+                          <a:spcPts val="0"/>
+                        </a:spcBef>
+                        <a:spcAft>
+                          <a:spcPts val="0"/>
+                        </a:spcAft>
+                        <a:buClrTx/>
+                        <a:buSzTx/>
+                        <a:buFontTx/>
+                        <a:buNone/>
+                        <a:tabLst/>
+                        <a:defRPr/>
+                      </a:pPr>
                       <a:r>
-                        <a:rPr lang="en-US" sz="1200" dirty="0"/>
-                        <a:t>Lower</a:t>
+                        <a:rPr lang="en-US" sz="1200" dirty="0" smtClean="0"/>
+                        <a:t>Higher</a:t>
                       </a:r>
+                      <a:endParaRPr lang="el-GR" sz="1200" dirty="0" smtClean="0"/>
+                    </a:p>
+                    <a:p>
                       <a:endParaRPr lang="el-GR" sz="1200" dirty="0"/>
                     </a:p>
                   </a:txBody>
@@ -5156,7 +5317,7 @@
                 </a:tc>
                 <a:extLst>
                   <a:ext uri="{0D108BD9-81ED-4DB2-BD59-A6C34878D82A}">
-                    <a16:rowId xmlns:a16="http://schemas.microsoft.com/office/drawing/2014/main" val="10002"/>
+                    <a16:rowId xmlns:a16="http://schemas.microsoft.com/office/drawing/2014/main" xmlns="" val="10002"/>
                   </a:ext>
                 </a:extLst>
               </a:tr>
@@ -5335,39 +5496,6 @@
           <a:chExt cx="0" cy="0"/>
         </a:xfrm>
       </p:grpSpPr>
-      <p:pic>
-        <p:nvPicPr>
-          <p:cNvPr id="4" name="Picture 3" descr="C:\Users\PC\Downloads\Learning_Curves_Combined(2).png"/>
-          <p:cNvPicPr/>
-          <p:nvPr/>
-        </p:nvPicPr>
-        <p:blipFill>
-          <a:blip r:embed="rId2" cstate="print">
-            <a:extLst>
-              <a:ext uri="{28A0092B-C50C-407E-A947-70E740481C1C}">
-                <a14:useLocalDpi xmlns:a14="http://schemas.microsoft.com/office/drawing/2010/main" val="0"/>
-              </a:ext>
-            </a:extLst>
-          </a:blip>
-          <a:srcRect/>
-          <a:stretch>
-            <a:fillRect/>
-          </a:stretch>
-        </p:blipFill>
-        <p:spPr bwMode="auto">
-          <a:xfrm>
-            <a:off x="304801" y="914400"/>
-            <a:ext cx="5181162" cy="2948081"/>
-          </a:xfrm>
-          <a:prstGeom prst="rect">
-            <a:avLst/>
-          </a:prstGeom>
-          <a:noFill/>
-          <a:ln>
-            <a:noFill/>
-          </a:ln>
-        </p:spPr>
-      </p:pic>
       <p:sp>
         <p:nvSpPr>
           <p:cNvPr id="5" name="Title 1"/>
@@ -5394,6 +5522,10 @@
               <a:rPr lang="en-US" sz="2400" b="1" dirty="0"/>
               <a:t>Training Phase	</a:t>
             </a:r>
+            <a:r>
+              <a:rPr lang="en-US" sz="2400" b="1" dirty="0" smtClean="0"/>
+              <a:t> of “Base” CNNs</a:t>
+            </a:r>
             <a:endParaRPr lang="el-GR" sz="2400" b="1" dirty="0"/>
           </a:p>
         </p:txBody>
@@ -5403,7 +5535,7 @@
           <p:cNvPr id="2" name="TextBox 1">
             <a:extLst>
               <a:ext uri="{FF2B5EF4-FFF2-40B4-BE49-F238E27FC236}">
-                <a16:creationId xmlns:a16="http://schemas.microsoft.com/office/drawing/2014/main" id="{FB302EDC-EEEF-81D2-576E-0A998837A79D}"/>
+                <a16:creationId xmlns:a16="http://schemas.microsoft.com/office/drawing/2014/main" xmlns="" id="{FB302EDC-EEEF-81D2-576E-0A998837A79D}"/>
               </a:ext>
             </a:extLst>
           </p:cNvPr>
@@ -5412,8 +5544,8 @@
         </p:nvSpPr>
         <p:spPr>
           <a:xfrm>
-            <a:off x="3330634" y="533400"/>
-            <a:ext cx="2482731" cy="369332"/>
+            <a:off x="5932294" y="5029200"/>
+            <a:ext cx="2529795" cy="369332"/>
           </a:xfrm>
           <a:prstGeom prst="rect">
             <a:avLst/>
@@ -5427,54 +5559,18 @@
           <a:lstStyle/>
           <a:p>
             <a:r>
-              <a:rPr lang="en-GR" dirty="0"/>
+              <a:rPr lang="x-none" b="1" dirty="0"/>
               <a:t>No Augmentation (Base)</a:t>
             </a:r>
           </a:p>
         </p:txBody>
       </p:sp>
-      <p:pic>
-        <p:nvPicPr>
-          <p:cNvPr id="11" name="Picture 10">
-            <a:extLst>
-              <a:ext uri="{FF2B5EF4-FFF2-40B4-BE49-F238E27FC236}">
-                <a16:creationId xmlns:a16="http://schemas.microsoft.com/office/drawing/2014/main" id="{F36F86C8-BB51-714A-54A2-AFAAD4E03DCA}"/>
-              </a:ext>
-            </a:extLst>
-          </p:cNvPr>
-          <p:cNvPicPr>
-            <a:picLocks noChangeAspect="1"/>
-          </p:cNvPicPr>
-          <p:nvPr/>
-        </p:nvPicPr>
-        <p:blipFill>
-          <a:blip r:embed="rId3">
-            <a:extLst>
-              <a:ext uri="{28A0092B-C50C-407E-A947-70E740481C1C}">
-                <a14:useLocalDpi xmlns:a14="http://schemas.microsoft.com/office/drawing/2010/main" val="0"/>
-              </a:ext>
-            </a:extLst>
-          </a:blip>
-          <a:stretch>
-            <a:fillRect/>
-          </a:stretch>
-        </p:blipFill>
-        <p:spPr>
-          <a:xfrm>
-            <a:off x="305239" y="3884707"/>
-            <a:ext cx="5181161" cy="2948080"/>
-          </a:xfrm>
-          <a:prstGeom prst="rect">
-            <a:avLst/>
-          </a:prstGeom>
-        </p:spPr>
-      </p:pic>
       <p:sp>
         <p:nvSpPr>
           <p:cNvPr id="12" name="TextBox 11">
             <a:extLst>
               <a:ext uri="{FF2B5EF4-FFF2-40B4-BE49-F238E27FC236}">
-                <a16:creationId xmlns:a16="http://schemas.microsoft.com/office/drawing/2014/main" id="{F18DC41E-0279-CBEA-6ED7-D98D5E4525C9}"/>
+                <a16:creationId xmlns:a16="http://schemas.microsoft.com/office/drawing/2014/main" xmlns="" id="{F18DC41E-0279-CBEA-6ED7-D98D5E4525C9}"/>
               </a:ext>
             </a:extLst>
           </p:cNvPr>
@@ -5483,8 +5579,8 @@
         </p:nvSpPr>
         <p:spPr>
           <a:xfrm>
-            <a:off x="5485963" y="1272540"/>
-            <a:ext cx="3355470" cy="1200329"/>
+            <a:off x="5514975" y="5429071"/>
+            <a:ext cx="3186770" cy="1138773"/>
           </a:xfrm>
           <a:prstGeom prst="rect">
             <a:avLst/>
@@ -5502,7 +5598,7 @@
               <a:buChar char="•"/>
             </a:pPr>
             <a:r>
-              <a:rPr lang="en-GB" dirty="0"/>
+              <a:rPr lang="en-GB" sz="1700" dirty="0"/>
               <a:t>Val Loss was going up or stable</a:t>
             </a:r>
           </a:p>
@@ -5512,7 +5608,7 @@
               <a:buChar char="•"/>
             </a:pPr>
             <a:r>
-              <a:rPr lang="en-GB" dirty="0"/>
+              <a:rPr lang="en-GB" sz="1700" dirty="0"/>
               <a:t>Train Loss ∼ 0</a:t>
             </a:r>
           </a:p>
@@ -5522,7 +5618,7 @@
               <a:buChar char="•"/>
             </a:pPr>
             <a:r>
-              <a:rPr lang="en-GB" dirty="0"/>
+              <a:rPr lang="en-GB" sz="1700" dirty="0"/>
               <a:t>Train F1-Score ∼ 1</a:t>
             </a:r>
           </a:p>
@@ -5532,14 +5628,14 @@
               <a:buChar char="•"/>
             </a:pPr>
             <a:r>
-              <a:rPr lang="en-GB" b="1" dirty="0">
+              <a:rPr lang="en-GB" sz="1700" b="1" dirty="0">
                 <a:solidFill>
                   <a:srgbClr val="FF0000"/>
                 </a:solidFill>
               </a:rPr>
               <a:t>Clear signs of overfitting</a:t>
             </a:r>
-            <a:endParaRPr lang="en-GR" b="1" dirty="0">
+            <a:endParaRPr lang="x-none" sz="1700" b="1" dirty="0">
               <a:solidFill>
                 <a:srgbClr val="FF0000"/>
               </a:solidFill>
@@ -5547,6 +5643,355 @@
           </a:p>
         </p:txBody>
       </p:sp>
+      <p:sp>
+        <p:nvSpPr>
+          <p:cNvPr id="3" name="Rectangle 2"/>
+          <p:cNvSpPr/>
+          <p:nvPr/>
+        </p:nvSpPr>
+        <p:spPr>
+          <a:xfrm>
+            <a:off x="5410200" y="2895600"/>
+            <a:ext cx="3565020" cy="1600438"/>
+          </a:xfrm>
+          <a:prstGeom prst="rect">
+            <a:avLst/>
+          </a:prstGeom>
+        </p:spPr>
+        <p:txBody>
+          <a:bodyPr wrap="square">
+            <a:spAutoFit/>
+          </a:bodyPr>
+          <a:lstStyle/>
+          <a:p>
+            <a:r>
+              <a:rPr lang="en-US" sz="1400" b="1" dirty="0" smtClean="0"/>
+              <a:t>(B)  DenseNet-121 </a:t>
+            </a:r>
+            <a:r>
+              <a:rPr lang="en-US" sz="1400" dirty="0" smtClean="0"/>
+              <a:t>[Base]</a:t>
+            </a:r>
+            <a:r>
+              <a:rPr lang="en-US" sz="1400" b="1" dirty="0" smtClean="0"/>
+              <a:t>: </a:t>
+            </a:r>
+          </a:p>
+          <a:p>
+            <a:r>
+              <a:rPr lang="en-US" sz="1400" u="sng" dirty="0" smtClean="0"/>
+              <a:t>Batch </a:t>
+            </a:r>
+            <a:r>
+              <a:rPr lang="en-US" sz="1400" u="sng" dirty="0"/>
+              <a:t>size</a:t>
+            </a:r>
+            <a:r>
+              <a:rPr lang="en-US" sz="1400" dirty="0"/>
+              <a:t> </a:t>
+            </a:r>
+            <a:r>
+              <a:rPr lang="en-US" sz="1400" dirty="0" smtClean="0"/>
+              <a:t>was 512 (initially) then reduced </a:t>
+            </a:r>
+            <a:r>
+              <a:rPr lang="en-US" sz="1400" dirty="0"/>
+              <a:t>to 256 from stage 4 onward. </a:t>
+            </a:r>
+            <a:endParaRPr lang="en-US" sz="1400" dirty="0" smtClean="0"/>
+          </a:p>
+          <a:p>
+            <a:r>
+              <a:rPr lang="en-US" sz="1400" u="sng" dirty="0" smtClean="0"/>
+              <a:t>Learning </a:t>
+            </a:r>
+            <a:r>
+              <a:rPr lang="en-US" sz="1400" u="sng" dirty="0"/>
+              <a:t>rate </a:t>
+            </a:r>
+            <a:r>
+              <a:rPr lang="en-US" sz="1400" dirty="0"/>
+              <a:t>was 1 × 10⁻⁴ for the first 3 stages and then reduced to 1 × 10⁻⁵</a:t>
+            </a:r>
+            <a:r>
+              <a:rPr lang="en-US" sz="1400" dirty="0" smtClean="0"/>
+              <a:t>.</a:t>
+            </a:r>
+          </a:p>
+          <a:p>
+            <a:r>
+              <a:rPr lang="en-US" sz="1400" u="sng" dirty="0"/>
+              <a:t>Early stopping:</a:t>
+            </a:r>
+            <a:r>
+              <a:rPr lang="en-US" sz="1400" dirty="0"/>
+              <a:t> patience of 5 for both macro F1-score (</a:t>
+            </a:r>
+            <a:r>
+              <a:rPr lang="en-US" sz="1400" dirty="0" err="1"/>
+              <a:t>Δmin</a:t>
+            </a:r>
+            <a:r>
+              <a:rPr lang="en-US" sz="1400" dirty="0"/>
+              <a:t> = 0.0005) and validation </a:t>
+            </a:r>
+            <a:r>
+              <a:rPr lang="en-US" sz="1400" dirty="0" smtClean="0"/>
+              <a:t>loss.</a:t>
+            </a:r>
+            <a:endParaRPr lang="el-GR" sz="1400" dirty="0"/>
+          </a:p>
+        </p:txBody>
+      </p:sp>
+      <p:sp>
+        <p:nvSpPr>
+          <p:cNvPr id="8" name="Rectangle 7"/>
+          <p:cNvSpPr/>
+          <p:nvPr/>
+        </p:nvSpPr>
+        <p:spPr>
+          <a:xfrm>
+            <a:off x="5410200" y="1345049"/>
+            <a:ext cx="3565020" cy="1169551"/>
+          </a:xfrm>
+          <a:prstGeom prst="rect">
+            <a:avLst/>
+          </a:prstGeom>
+        </p:spPr>
+        <p:txBody>
+          <a:bodyPr wrap="square">
+            <a:spAutoFit/>
+          </a:bodyPr>
+          <a:lstStyle/>
+          <a:p>
+            <a:r>
+              <a:rPr lang="en-US" sz="1400" b="1" dirty="0" smtClean="0"/>
+              <a:t>(A)  RensNet-18  </a:t>
+            </a:r>
+            <a:r>
+              <a:rPr lang="en-US" sz="1400" dirty="0" smtClean="0"/>
+              <a:t>[Base] </a:t>
+            </a:r>
+            <a:r>
+              <a:rPr lang="en-US" sz="1400" b="1" dirty="0" smtClean="0"/>
+              <a:t>:  </a:t>
+            </a:r>
+          </a:p>
+          <a:p>
+            <a:r>
+              <a:rPr lang="en-US" sz="1400" u="sng" dirty="0" smtClean="0"/>
+              <a:t>Batch </a:t>
+            </a:r>
+            <a:r>
+              <a:rPr lang="en-US" sz="1400" u="sng" dirty="0"/>
+              <a:t>size</a:t>
+            </a:r>
+            <a:r>
+              <a:rPr lang="en-US" sz="1400" dirty="0"/>
+              <a:t> </a:t>
+            </a:r>
+            <a:r>
+              <a:rPr lang="en-US" sz="1400" dirty="0" smtClean="0"/>
+              <a:t>was consistently 512. </a:t>
+            </a:r>
+          </a:p>
+          <a:p>
+            <a:r>
+              <a:rPr lang="en-US" sz="1400" u="sng" dirty="0" smtClean="0"/>
+              <a:t>Learning </a:t>
+            </a:r>
+            <a:r>
+              <a:rPr lang="en-US" sz="1400" u="sng" dirty="0"/>
+              <a:t>rate </a:t>
+            </a:r>
+            <a:r>
+              <a:rPr lang="en-US" sz="1400" dirty="0"/>
+              <a:t>was </a:t>
+            </a:r>
+            <a:r>
+              <a:rPr lang="en-US" sz="1400" dirty="0" smtClean="0"/>
+              <a:t>resetting to 1 </a:t>
+            </a:r>
+            <a:r>
+              <a:rPr lang="en-US" sz="1400" dirty="0"/>
+              <a:t>× 10</a:t>
+            </a:r>
+            <a:r>
+              <a:rPr lang="en-US" sz="1400" dirty="0" smtClean="0"/>
+              <a:t>⁻⁴.</a:t>
+            </a:r>
+          </a:p>
+          <a:p>
+            <a:r>
+              <a:rPr lang="en-US" sz="1400" u="sng" dirty="0" smtClean="0"/>
+              <a:t>Early stopping:</a:t>
+            </a:r>
+            <a:r>
+              <a:rPr lang="en-US" sz="1400" dirty="0" smtClean="0"/>
+              <a:t> patience </a:t>
+            </a:r>
+            <a:r>
+              <a:rPr lang="en-US" sz="1400" dirty="0"/>
+              <a:t>of 3 epochs (</a:t>
+            </a:r>
+            <a:r>
+              <a:rPr lang="en-US" sz="1400" dirty="0" err="1"/>
+              <a:t>Δmin</a:t>
+            </a:r>
+            <a:r>
+              <a:rPr lang="en-US" sz="1400" dirty="0"/>
+              <a:t> = 0.0005) based on macro </a:t>
+            </a:r>
+            <a:r>
+              <a:rPr lang="en-US" sz="1400" dirty="0" smtClean="0"/>
+              <a:t>F1-Score.</a:t>
+            </a:r>
+            <a:endParaRPr lang="el-GR" sz="1400" dirty="0"/>
+          </a:p>
+        </p:txBody>
+      </p:sp>
+      <p:grpSp>
+        <p:nvGrpSpPr>
+          <p:cNvPr id="7" name="Group 6"/>
+          <p:cNvGrpSpPr/>
+          <p:nvPr/>
+        </p:nvGrpSpPr>
+        <p:grpSpPr>
+          <a:xfrm>
+            <a:off x="152400" y="902732"/>
+            <a:ext cx="5181162" cy="5871280"/>
+            <a:chOff x="152400" y="902732"/>
+            <a:chExt cx="5181162" cy="5871280"/>
+          </a:xfrm>
+        </p:grpSpPr>
+        <p:pic>
+          <p:nvPicPr>
+            <p:cNvPr id="4" name="Picture 3" descr="C:\Users\PC\Downloads\Learning_Curves_Combined(2).png"/>
+            <p:cNvPicPr/>
+            <p:nvPr/>
+          </p:nvPicPr>
+          <p:blipFill>
+            <a:blip r:embed="rId2" cstate="print">
+              <a:extLst>
+                <a:ext uri="{28A0092B-C50C-407E-A947-70E740481C1C}">
+                  <a14:useLocalDpi xmlns:a14="http://schemas.microsoft.com/office/drawing/2010/main" val="0"/>
+                </a:ext>
+              </a:extLst>
+            </a:blip>
+            <a:srcRect/>
+            <a:stretch>
+              <a:fillRect/>
+            </a:stretch>
+          </p:blipFill>
+          <p:spPr bwMode="auto">
+            <a:xfrm>
+              <a:off x="152400" y="3850812"/>
+              <a:ext cx="5181162" cy="2923200"/>
+            </a:xfrm>
+            <a:prstGeom prst="rect">
+              <a:avLst/>
+            </a:prstGeom>
+            <a:noFill/>
+            <a:ln>
+              <a:noFill/>
+            </a:ln>
+          </p:spPr>
+        </p:pic>
+        <p:pic>
+          <p:nvPicPr>
+            <p:cNvPr id="11" name="Picture 10">
+              <a:extLst>
+                <a:ext uri="{FF2B5EF4-FFF2-40B4-BE49-F238E27FC236}">
+                  <a16:creationId xmlns:a16="http://schemas.microsoft.com/office/drawing/2014/main" xmlns="" id="{F36F86C8-BB51-714A-54A2-AFAAD4E03DCA}"/>
+                </a:ext>
+              </a:extLst>
+            </p:cNvPr>
+            <p:cNvPicPr>
+              <a:picLocks noChangeAspect="1"/>
+            </p:cNvPicPr>
+            <p:nvPr/>
+          </p:nvPicPr>
+          <p:blipFill>
+            <a:blip r:embed="rId3" cstate="print">
+              <a:extLst>
+                <a:ext uri="{28A0092B-C50C-407E-A947-70E740481C1C}">
+                  <a14:useLocalDpi xmlns:a14="http://schemas.microsoft.com/office/drawing/2010/main" val="0"/>
+                </a:ext>
+              </a:extLst>
+            </a:blip>
+            <a:stretch>
+              <a:fillRect/>
+            </a:stretch>
+          </p:blipFill>
+          <p:spPr>
+            <a:xfrm>
+              <a:off x="152400" y="902732"/>
+              <a:ext cx="5181161" cy="2948080"/>
+            </a:xfrm>
+            <a:prstGeom prst="rect">
+              <a:avLst/>
+            </a:prstGeom>
+          </p:spPr>
+        </p:pic>
+        <p:sp>
+          <p:nvSpPr>
+            <p:cNvPr id="6" name="Rectangle 5"/>
+            <p:cNvSpPr/>
+            <p:nvPr/>
+          </p:nvSpPr>
+          <p:spPr>
+            <a:xfrm>
+              <a:off x="390525" y="1207532"/>
+              <a:ext cx="521297" cy="369332"/>
+            </a:xfrm>
+            <a:prstGeom prst="rect">
+              <a:avLst/>
+            </a:prstGeom>
+          </p:spPr>
+          <p:txBody>
+            <a:bodyPr wrap="none">
+              <a:spAutoFit/>
+            </a:bodyPr>
+            <a:lstStyle/>
+            <a:p>
+              <a:r>
+                <a:rPr lang="en-US" b="1" dirty="0"/>
+                <a:t>(A) </a:t>
+              </a:r>
+              <a:endParaRPr lang="el-GR" dirty="0"/>
+            </a:p>
+          </p:txBody>
+        </p:sp>
+        <p:sp>
+          <p:nvSpPr>
+            <p:cNvPr id="10" name="Rectangle 9"/>
+            <p:cNvSpPr/>
+            <p:nvPr/>
+          </p:nvSpPr>
+          <p:spPr>
+            <a:xfrm>
+              <a:off x="359372" y="4191000"/>
+              <a:ext cx="511679" cy="369332"/>
+            </a:xfrm>
+            <a:prstGeom prst="rect">
+              <a:avLst/>
+            </a:prstGeom>
+          </p:spPr>
+          <p:txBody>
+            <a:bodyPr wrap="none">
+              <a:spAutoFit/>
+            </a:bodyPr>
+            <a:lstStyle/>
+            <a:p>
+              <a:r>
+                <a:rPr lang="en-US" b="1" dirty="0" smtClean="0"/>
+                <a:t>(B) </a:t>
+              </a:r>
+              <a:endParaRPr lang="el-GR" dirty="0"/>
+            </a:p>
+          </p:txBody>
+        </p:sp>
+      </p:grpSp>
     </p:spTree>
     <p:extLst>
       <p:ext uri="{BB962C8B-B14F-4D97-AF65-F5344CB8AC3E}">
@@ -5577,37 +6022,6 @@
           <a:chExt cx="0" cy="0"/>
         </a:xfrm>
       </p:grpSpPr>
-      <p:pic>
-        <p:nvPicPr>
-          <p:cNvPr id="4" name="Picture 3"/>
-          <p:cNvPicPr/>
-          <p:nvPr/>
-        </p:nvPicPr>
-        <p:blipFill>
-          <a:blip r:embed="rId2">
-            <a:extLst>
-              <a:ext uri="{28A0092B-C50C-407E-A947-70E740481C1C}">
-                <a14:useLocalDpi xmlns:a14="http://schemas.microsoft.com/office/drawing/2010/main" val="0"/>
-              </a:ext>
-            </a:extLst>
-          </a:blip>
-          <a:srcRect/>
-          <a:stretch/>
-        </p:blipFill>
-        <p:spPr bwMode="auto">
-          <a:xfrm>
-            <a:off x="304801" y="914400"/>
-            <a:ext cx="5181161" cy="2948081"/>
-          </a:xfrm>
-          <a:prstGeom prst="rect">
-            <a:avLst/>
-          </a:prstGeom>
-          <a:noFill/>
-          <a:ln>
-            <a:noFill/>
-          </a:ln>
-        </p:spPr>
-      </p:pic>
       <p:sp>
         <p:nvSpPr>
           <p:cNvPr id="5" name="Title 1"/>
@@ -5634,16 +6048,28 @@
               <a:rPr lang="en-US" sz="2400" b="1" dirty="0"/>
               <a:t>Training Phase	</a:t>
             </a:r>
+            <a:r>
+              <a:rPr lang="en-US" sz="2400" b="1" dirty="0" smtClean="0"/>
+              <a:t> of CNNs including “</a:t>
+            </a:r>
+            <a:r>
+              <a:rPr lang="x-none" sz="2400" b="1" smtClean="0"/>
+              <a:t>Augmentation</a:t>
+            </a:r>
+            <a:r>
+              <a:rPr lang="en-US" sz="2400" b="1" dirty="0" smtClean="0"/>
+              <a:t>”</a:t>
+            </a:r>
             <a:endParaRPr lang="el-GR" sz="2400" b="1" dirty="0"/>
           </a:p>
         </p:txBody>
       </p:sp>
       <p:sp>
         <p:nvSpPr>
-          <p:cNvPr id="2" name="TextBox 1">
+          <p:cNvPr id="12" name="TextBox 11">
             <a:extLst>
               <a:ext uri="{FF2B5EF4-FFF2-40B4-BE49-F238E27FC236}">
-                <a16:creationId xmlns:a16="http://schemas.microsoft.com/office/drawing/2014/main" id="{FB302EDC-EEEF-81D2-576E-0A998837A79D}"/>
+                <a16:creationId xmlns:a16="http://schemas.microsoft.com/office/drawing/2014/main" xmlns="" id="{F18DC41E-0279-CBEA-6ED7-D98D5E4525C9}"/>
               </a:ext>
             </a:extLst>
           </p:cNvPr>
@@ -5652,8 +6078,8 @@
         </p:nvSpPr>
         <p:spPr>
           <a:xfrm>
-            <a:off x="3809932" y="545068"/>
-            <a:ext cx="1524135" cy="369332"/>
+            <a:off x="5327865" y="5410200"/>
+            <a:ext cx="3739935" cy="1138773"/>
           </a:xfrm>
           <a:prstGeom prst="rect">
             <a:avLst/>
@@ -5666,54 +6092,201 @@
           </a:bodyPr>
           <a:lstStyle/>
           <a:p>
-            <a:r>
-              <a:rPr lang="en-GR" dirty="0"/>
-              <a:t>Augmentation</a:t>
-            </a:r>
+            <a:pPr marL="285750" indent="-285750">
+              <a:buFont typeface="Arial" panose="020B0604020202020204" pitchFamily="34" charset="0"/>
+              <a:buChar char="•"/>
+            </a:pPr>
+            <a:r>
+              <a:rPr lang="en-GB" sz="1700" dirty="0"/>
+              <a:t>Smaller Val Loss</a:t>
+            </a:r>
+          </a:p>
+          <a:p>
+            <a:pPr marL="285750" indent="-285750">
+              <a:buFont typeface="Arial" panose="020B0604020202020204" pitchFamily="34" charset="0"/>
+              <a:buChar char="•"/>
+            </a:pPr>
+            <a:r>
+              <a:rPr lang="en-GB" sz="1700" dirty="0"/>
+              <a:t>Train Loss ∼ Val Loss (Generalization)</a:t>
+            </a:r>
+          </a:p>
+          <a:p>
+            <a:pPr marL="285750" indent="-285750">
+              <a:buFont typeface="Arial" panose="020B0604020202020204" pitchFamily="34" charset="0"/>
+              <a:buChar char="•"/>
+            </a:pPr>
+            <a:r>
+              <a:rPr lang="en-GB" sz="1700" dirty="0"/>
+              <a:t>Train F1-Score ∼ Val F1-Score</a:t>
+            </a:r>
+          </a:p>
+          <a:p>
+            <a:pPr marL="285750" indent="-285750">
+              <a:buFont typeface="Arial" panose="020B0604020202020204" pitchFamily="34" charset="0"/>
+              <a:buChar char="•"/>
+            </a:pPr>
+            <a:r>
+              <a:rPr lang="en-GB" sz="1700" b="1" dirty="0">
+                <a:solidFill>
+                  <a:srgbClr val="00B050"/>
+                </a:solidFill>
+              </a:rPr>
+              <a:t>Better Training</a:t>
+            </a:r>
+            <a:endParaRPr lang="x-none" sz="1700" b="1" dirty="0">
+              <a:solidFill>
+                <a:srgbClr val="00B050"/>
+              </a:solidFill>
+            </a:endParaRPr>
           </a:p>
         </p:txBody>
       </p:sp>
-      <p:pic>
-        <p:nvPicPr>
-          <p:cNvPr id="11" name="Picture 10">
+      <p:grpSp>
+        <p:nvGrpSpPr>
+          <p:cNvPr id="3" name="Group 2"/>
+          <p:cNvGrpSpPr/>
+          <p:nvPr/>
+        </p:nvGrpSpPr>
+        <p:grpSpPr>
+          <a:xfrm>
+            <a:off x="133350" y="838200"/>
+            <a:ext cx="5200211" cy="5818800"/>
+            <a:chOff x="133350" y="914400"/>
+            <a:chExt cx="5200211" cy="5818800"/>
+          </a:xfrm>
+        </p:grpSpPr>
+        <p:pic>
+          <p:nvPicPr>
+            <p:cNvPr id="4" name="Picture 3"/>
+            <p:cNvPicPr/>
+            <p:nvPr/>
+          </p:nvPicPr>
+          <p:blipFill>
+            <a:blip r:embed="rId2" cstate="print">
+              <a:extLst>
+                <a:ext uri="{28A0092B-C50C-407E-A947-70E740481C1C}">
+                  <a14:useLocalDpi xmlns:a14="http://schemas.microsoft.com/office/drawing/2010/main" val="0"/>
+                </a:ext>
+              </a:extLst>
+            </a:blip>
+            <a:srcRect/>
+            <a:stretch/>
+          </p:blipFill>
+          <p:spPr bwMode="auto">
+            <a:xfrm>
+              <a:off x="133350" y="3810000"/>
+              <a:ext cx="5181161" cy="2923200"/>
+            </a:xfrm>
+            <a:prstGeom prst="rect">
+              <a:avLst/>
+            </a:prstGeom>
+            <a:noFill/>
+            <a:ln>
+              <a:noFill/>
+            </a:ln>
+          </p:spPr>
+        </p:pic>
+        <p:pic>
+          <p:nvPicPr>
+            <p:cNvPr id="11" name="Picture 10">
+              <a:extLst>
+                <a:ext uri="{FF2B5EF4-FFF2-40B4-BE49-F238E27FC236}">
+                  <a16:creationId xmlns:a16="http://schemas.microsoft.com/office/drawing/2014/main" xmlns="" id="{F36F86C8-BB51-714A-54A2-AFAAD4E03DCA}"/>
+                </a:ext>
+              </a:extLst>
+            </p:cNvPr>
+            <p:cNvPicPr>
+              <a:picLocks noChangeAspect="1"/>
+            </p:cNvPicPr>
+            <p:nvPr/>
+          </p:nvPicPr>
+          <p:blipFill>
+            <a:blip r:embed="rId3" cstate="print">
+              <a:extLst>
+                <a:ext uri="{28A0092B-C50C-407E-A947-70E740481C1C}">
+                  <a14:useLocalDpi xmlns:a14="http://schemas.microsoft.com/office/drawing/2010/main" val="0"/>
+                </a:ext>
+              </a:extLst>
+            </a:blip>
+            <a:srcRect/>
+            <a:stretch/>
+          </p:blipFill>
+          <p:spPr>
+            <a:xfrm>
+              <a:off x="152400" y="914400"/>
+              <a:ext cx="5181161" cy="2921784"/>
+            </a:xfrm>
+            <a:prstGeom prst="rect">
+              <a:avLst/>
+            </a:prstGeom>
+          </p:spPr>
+        </p:pic>
+        <p:sp>
+          <p:nvSpPr>
+            <p:cNvPr id="7" name="Rectangle 6"/>
+            <p:cNvSpPr/>
+            <p:nvPr/>
+          </p:nvSpPr>
+          <p:spPr>
+            <a:xfrm>
+              <a:off x="390525" y="1207532"/>
+              <a:ext cx="503664" cy="369332"/>
+            </a:xfrm>
+            <a:prstGeom prst="rect">
+              <a:avLst/>
+            </a:prstGeom>
+          </p:spPr>
+          <p:txBody>
+            <a:bodyPr wrap="none">
+              <a:spAutoFit/>
+            </a:bodyPr>
+            <a:lstStyle/>
+            <a:p>
+              <a:r>
+                <a:rPr lang="en-US" b="1" dirty="0" smtClean="0"/>
+                <a:t>(C) </a:t>
+              </a:r>
+              <a:endParaRPr lang="el-GR" dirty="0"/>
+            </a:p>
+          </p:txBody>
+        </p:sp>
+        <p:sp>
+          <p:nvSpPr>
+            <p:cNvPr id="8" name="Rectangle 7"/>
+            <p:cNvSpPr/>
+            <p:nvPr/>
+          </p:nvSpPr>
+          <p:spPr>
+            <a:xfrm>
+              <a:off x="372892" y="4114800"/>
+              <a:ext cx="527709" cy="369332"/>
+            </a:xfrm>
+            <a:prstGeom prst="rect">
+              <a:avLst/>
+            </a:prstGeom>
+          </p:spPr>
+          <p:txBody>
+            <a:bodyPr wrap="none">
+              <a:spAutoFit/>
+            </a:bodyPr>
+            <a:lstStyle/>
+            <a:p>
+              <a:r>
+                <a:rPr lang="en-US" b="1" dirty="0" smtClean="0"/>
+                <a:t>(D) </a:t>
+              </a:r>
+              <a:endParaRPr lang="el-GR" dirty="0"/>
+            </a:p>
+          </p:txBody>
+        </p:sp>
+      </p:grpSp>
+      <p:sp>
+        <p:nvSpPr>
+          <p:cNvPr id="10" name="TextBox 9">
             <a:extLst>
               <a:ext uri="{FF2B5EF4-FFF2-40B4-BE49-F238E27FC236}">
-                <a16:creationId xmlns:a16="http://schemas.microsoft.com/office/drawing/2014/main" id="{F36F86C8-BB51-714A-54A2-AFAAD4E03DCA}"/>
-              </a:ext>
-            </a:extLst>
-          </p:cNvPr>
-          <p:cNvPicPr>
-            <a:picLocks noChangeAspect="1"/>
-          </p:cNvPicPr>
-          <p:nvPr/>
-        </p:nvPicPr>
-        <p:blipFill>
-          <a:blip r:embed="rId3">
-            <a:extLst>
-              <a:ext uri="{28A0092B-C50C-407E-A947-70E740481C1C}">
-                <a14:useLocalDpi xmlns:a14="http://schemas.microsoft.com/office/drawing/2010/main" val="0"/>
-              </a:ext>
-            </a:extLst>
-          </a:blip>
-          <a:srcRect/>
-          <a:stretch/>
-        </p:blipFill>
-        <p:spPr>
-          <a:xfrm>
-            <a:off x="305239" y="3897855"/>
-            <a:ext cx="5181161" cy="2921784"/>
-          </a:xfrm>
-          <a:prstGeom prst="rect">
-            <a:avLst/>
-          </a:prstGeom>
-        </p:spPr>
-      </p:pic>
-      <p:sp>
-        <p:nvSpPr>
-          <p:cNvPr id="12" name="TextBox 11">
-            <a:extLst>
-              <a:ext uri="{FF2B5EF4-FFF2-40B4-BE49-F238E27FC236}">
-                <a16:creationId xmlns:a16="http://schemas.microsoft.com/office/drawing/2014/main" id="{F18DC41E-0279-CBEA-6ED7-D98D5E4525C9}"/>
+                <a16:creationId xmlns:a16="http://schemas.microsoft.com/office/drawing/2014/main" xmlns="" id="{FB302EDC-EEEF-81D2-576E-0A998837A79D}"/>
               </a:ext>
             </a:extLst>
           </p:cNvPr>
@@ -5722,8 +6295,8 @@
         </p:nvSpPr>
         <p:spPr>
           <a:xfrm>
-            <a:off x="5353589" y="1272540"/>
-            <a:ext cx="3942811" cy="1200329"/>
+            <a:off x="6019800" y="5040868"/>
+            <a:ext cx="2076146" cy="369332"/>
           </a:xfrm>
           <a:prstGeom prst="rect">
             <a:avLst/>
@@ -5736,53 +6309,196 @@
           </a:bodyPr>
           <a:lstStyle/>
           <a:p>
-            <a:pPr marL="285750" indent="-285750">
-              <a:buFont typeface="Arial" panose="020B0604020202020204" pitchFamily="34" charset="0"/>
-              <a:buChar char="•"/>
-            </a:pPr>
-            <a:r>
-              <a:rPr lang="en-GB" dirty="0"/>
-              <a:t>Smaller Val Loss</a:t>
-            </a:r>
-          </a:p>
-          <a:p>
-            <a:pPr marL="285750" indent="-285750">
-              <a:buFont typeface="Arial" panose="020B0604020202020204" pitchFamily="34" charset="0"/>
-              <a:buChar char="•"/>
-            </a:pPr>
-            <a:r>
-              <a:rPr lang="en-GB" dirty="0"/>
-              <a:t>Train Loss ∼ Val Loss (Generalization)</a:t>
-            </a:r>
-          </a:p>
-          <a:p>
-            <a:pPr marL="285750" indent="-285750">
-              <a:buFont typeface="Arial" panose="020B0604020202020204" pitchFamily="34" charset="0"/>
-              <a:buChar char="•"/>
-            </a:pPr>
-            <a:r>
-              <a:rPr lang="en-GB" dirty="0"/>
-              <a:t>Train F1-Score ∼ Val F1-Score</a:t>
-            </a:r>
-          </a:p>
-          <a:p>
-            <a:pPr marL="285750" indent="-285750">
-              <a:buFont typeface="Arial" panose="020B0604020202020204" pitchFamily="34" charset="0"/>
-              <a:buChar char="•"/>
-            </a:pPr>
-            <a:r>
-              <a:rPr lang="en-GB" b="1" dirty="0">
+            <a:r>
+              <a:rPr lang="en-US" b="1" dirty="0" smtClean="0"/>
+              <a:t>With </a:t>
+            </a:r>
+            <a:r>
+              <a:rPr lang="x-none" b="1" smtClean="0"/>
+              <a:t>Augmentation</a:t>
+            </a:r>
+            <a:endParaRPr lang="x-none" b="1" dirty="0"/>
+          </a:p>
+        </p:txBody>
+      </p:sp>
+      <p:sp>
+        <p:nvSpPr>
+          <p:cNvPr id="14" name="Rectangle 13"/>
+          <p:cNvSpPr/>
+          <p:nvPr/>
+        </p:nvSpPr>
+        <p:spPr>
+          <a:xfrm>
+            <a:off x="5400675" y="1013936"/>
+            <a:ext cx="3574545" cy="738664"/>
+          </a:xfrm>
+          <a:prstGeom prst="rect">
+            <a:avLst/>
+          </a:prstGeom>
+        </p:spPr>
+        <p:txBody>
+          <a:bodyPr wrap="square">
+            <a:spAutoFit/>
+          </a:bodyPr>
+          <a:lstStyle/>
+          <a:p>
+            <a:r>
+              <a:rPr lang="en-US" sz="1400" b="1" dirty="0" smtClean="0"/>
+              <a:t>(C)  RensNet-18  </a:t>
+            </a:r>
+            <a:r>
+              <a:rPr lang="en-US" sz="1400" dirty="0" smtClean="0"/>
+              <a:t>[Augmented] </a:t>
+            </a:r>
+            <a:r>
+              <a:rPr lang="en-US" sz="1400" b="1" dirty="0" smtClean="0"/>
+              <a:t>:  </a:t>
+            </a:r>
+          </a:p>
+          <a:p>
+            <a:r>
+              <a:rPr lang="en-US" sz="1400" u="sng" dirty="0" smtClean="0"/>
+              <a:t>F1-score</a:t>
+            </a:r>
+            <a:r>
+              <a:rPr lang="en-US" sz="1400" dirty="0" smtClean="0"/>
+              <a:t> improved to 0.9489. </a:t>
+            </a:r>
+          </a:p>
+          <a:p>
+            <a:r>
+              <a:rPr lang="en-US" sz="1400" u="sng" dirty="0" smtClean="0"/>
+              <a:t>ECE</a:t>
+            </a:r>
+            <a:r>
+              <a:rPr lang="en-US" sz="1400" dirty="0" smtClean="0"/>
+              <a:t> reduced to 0.0080.</a:t>
+            </a:r>
+          </a:p>
+        </p:txBody>
+      </p:sp>
+      <p:sp>
+        <p:nvSpPr>
+          <p:cNvPr id="15" name="Rectangle 14"/>
+          <p:cNvSpPr/>
+          <p:nvPr/>
+        </p:nvSpPr>
+        <p:spPr>
+          <a:xfrm>
+            <a:off x="5400675" y="2133362"/>
+            <a:ext cx="3565020" cy="1600438"/>
+          </a:xfrm>
+          <a:prstGeom prst="rect">
+            <a:avLst/>
+          </a:prstGeom>
+        </p:spPr>
+        <p:txBody>
+          <a:bodyPr wrap="square">
+            <a:spAutoFit/>
+          </a:bodyPr>
+          <a:lstStyle/>
+          <a:p>
+            <a:r>
+              <a:rPr lang="en-US" sz="1400" b="1" dirty="0" smtClean="0"/>
+              <a:t>(D)  DenseNet-121  </a:t>
+            </a:r>
+            <a:r>
+              <a:rPr lang="en-US" sz="1400" dirty="0" smtClean="0"/>
+              <a:t>[Augmented] </a:t>
+            </a:r>
+            <a:r>
+              <a:rPr lang="en-US" sz="1400" b="1" dirty="0" smtClean="0"/>
+              <a:t>:  </a:t>
+            </a:r>
+          </a:p>
+          <a:p>
+            <a:r>
+              <a:rPr lang="en-US" sz="1400" u="sng" dirty="0" smtClean="0"/>
+              <a:t>F1-score</a:t>
+            </a:r>
+            <a:r>
+              <a:rPr lang="en-US" sz="1400" dirty="0" smtClean="0"/>
+              <a:t> improved to 0.9531. </a:t>
+            </a:r>
+          </a:p>
+          <a:p>
+            <a:r>
+              <a:rPr lang="en-US" sz="1400" u="sng" dirty="0" smtClean="0"/>
+              <a:t>ECE</a:t>
+            </a:r>
+            <a:r>
+              <a:rPr lang="en-US" sz="1400" dirty="0" smtClean="0"/>
+              <a:t> reduced to 0.0081.</a:t>
+            </a:r>
+          </a:p>
+          <a:p>
+            <a:endParaRPr lang="en-US" sz="1400" dirty="0"/>
+          </a:p>
+          <a:p>
+            <a:pPr algn="just"/>
+            <a:r>
+              <a:rPr lang="en-US" sz="1400" dirty="0"/>
+              <a:t>Total misclassifications for test set above threshold were </a:t>
+            </a:r>
+            <a:r>
+              <a:rPr lang="en-US" sz="1400" u="sng" dirty="0"/>
+              <a:t>only 222</a:t>
+            </a:r>
+            <a:r>
+              <a:rPr lang="en-US" sz="1400" dirty="0"/>
+              <a:t> out of 16,699 samples (1.3%). </a:t>
+            </a:r>
+            <a:endParaRPr lang="en-US" sz="800" dirty="0"/>
+          </a:p>
+        </p:txBody>
+      </p:sp>
+      <p:sp>
+        <p:nvSpPr>
+          <p:cNvPr id="16" name="Rectangle 15"/>
+          <p:cNvSpPr/>
+          <p:nvPr/>
+        </p:nvSpPr>
+        <p:spPr>
+          <a:xfrm>
+            <a:off x="5486400" y="4001869"/>
+            <a:ext cx="3352800" cy="646331"/>
+          </a:xfrm>
+          <a:prstGeom prst="rect">
+            <a:avLst/>
+          </a:prstGeom>
+        </p:spPr>
+        <p:txBody>
+          <a:bodyPr wrap="square">
+            <a:spAutoFit/>
+          </a:bodyPr>
+          <a:lstStyle/>
+          <a:p>
+            <a:pPr algn="just"/>
+            <a:r>
+              <a:rPr lang="en-US" sz="1200" dirty="0"/>
+              <a:t>*Hard-case mining revealed </a:t>
+            </a:r>
+            <a:r>
+              <a:rPr lang="en-US" sz="1200" dirty="0">
                 <a:solidFill>
-                  <a:srgbClr val="00B050"/>
+                  <a:srgbClr val="FF0000"/>
                 </a:solidFill>
               </a:rPr>
-              <a:t>Better Training</a:t>
-            </a:r>
-            <a:endParaRPr lang="en-GR" b="1" dirty="0">
-              <a:solidFill>
-                <a:srgbClr val="00B050"/>
-              </a:solidFill>
-            </a:endParaRPr>
+              <a:t>327 high-confidence misclassifications within the training set</a:t>
+            </a:r>
+            <a:r>
+              <a:rPr lang="en-US" sz="1200" dirty="0"/>
+              <a:t>, mainly for CNV and </a:t>
+            </a:r>
+            <a:r>
+              <a:rPr lang="en-US" sz="1200" dirty="0" err="1"/>
+              <a:t>Drusen</a:t>
+            </a:r>
+            <a:r>
+              <a:rPr lang="en-US" sz="1200" dirty="0"/>
+              <a:t>.</a:t>
+            </a:r>
+            <a:endParaRPr lang="el-GR" sz="1200" dirty="0"/>
           </a:p>
         </p:txBody>
       </p:sp>
@@ -6150,7 +6866,7 @@
                             </a:spcAft>
                           </a:pPr>
                           <a:r>
-                            <a:rPr lang="fr-FR" sz="900" b="1" u="sng">
+                            <a:rPr lang="fr-FR" sz="900" b="1" u="sng" dirty="0">
                               <a:effectLst/>
                               <a:latin typeface="Calibri"/>
                               <a:ea typeface="Calibri"/>
@@ -6158,7 +6874,7 @@
                             </a:rPr>
                             <a:t>AUC values</a:t>
                           </a:r>
-                          <a:endParaRPr lang="el-GR" sz="1100">
+                          <a:endParaRPr lang="el-GR" sz="1100" dirty="0">
                             <a:effectLst/>
                             <a:latin typeface="Calibri"/>
                             <a:ea typeface="Calibri"/>
@@ -6175,7 +6891,7 @@
                             </a:spcAft>
                           </a:pPr>
                           <a:r>
-                            <a:rPr lang="fr-FR" sz="800">
+                            <a:rPr lang="fr-FR" sz="800" dirty="0">
                               <a:effectLst/>
                               <a:latin typeface="Calibri"/>
                               <a:ea typeface="Calibri"/>
@@ -6184,7 +6900,7 @@
                             <a:t>CNV </a:t>
                           </a:r>
                           <a:r>
-                            <a:rPr lang="en-US" sz="700">
+                            <a:rPr lang="en-US" sz="800" dirty="0">
                               <a:effectLst/>
                               <a:latin typeface="Calibri"/>
                               <a:ea typeface="Calibri"/>
@@ -6194,7 +6910,7 @@
                             <a:t></a:t>
                           </a:r>
                           <a:r>
-                            <a:rPr lang="fr-FR" sz="700">
+                            <a:rPr lang="fr-FR" sz="800" dirty="0">
                               <a:effectLst/>
                               <a:latin typeface="Calibri"/>
                               <a:ea typeface="Calibri"/>
@@ -6202,7 +6918,7 @@
                             </a:rPr>
                             <a:t> 0.998</a:t>
                           </a:r>
-                          <a:endParaRPr lang="el-GR" sz="1100">
+                          <a:endParaRPr lang="el-GR" sz="800" dirty="0">
                             <a:effectLst/>
                             <a:latin typeface="Calibri"/>
                             <a:ea typeface="Calibri"/>
@@ -6219,7 +6935,7 @@
                             </a:spcAft>
                           </a:pPr>
                           <a:r>
-                            <a:rPr lang="fr-FR" sz="800">
+                            <a:rPr lang="fr-FR" sz="800" dirty="0">
                               <a:effectLst/>
                               <a:latin typeface="Calibri"/>
                               <a:ea typeface="Calibri"/>
@@ -6228,7 +6944,7 @@
                             <a:t>DME </a:t>
                           </a:r>
                           <a:r>
-                            <a:rPr lang="en-US" sz="700">
+                            <a:rPr lang="en-US" sz="800" dirty="0">
                               <a:effectLst/>
                               <a:latin typeface="Calibri"/>
                               <a:ea typeface="Calibri"/>
@@ -6238,7 +6954,7 @@
                             <a:t></a:t>
                           </a:r>
                           <a:r>
-                            <a:rPr lang="fr-FR" sz="700">
+                            <a:rPr lang="fr-FR" sz="800" dirty="0">
                               <a:effectLst/>
                               <a:latin typeface="Calibri"/>
                               <a:ea typeface="Calibri"/>
@@ -6246,7 +6962,7 @@
                             </a:rPr>
                             <a:t> 0.997</a:t>
                           </a:r>
-                          <a:endParaRPr lang="el-GR" sz="1100">
+                          <a:endParaRPr lang="el-GR" sz="800" dirty="0">
                             <a:effectLst/>
                             <a:latin typeface="Calibri"/>
                             <a:ea typeface="Calibri"/>
@@ -6263,7 +6979,7 @@
                             </a:spcAft>
                           </a:pPr>
                           <a:r>
-                            <a:rPr lang="fr-FR" sz="800">
+                            <a:rPr lang="fr-FR" sz="800" dirty="0">
                               <a:effectLst/>
                               <a:latin typeface="Calibri"/>
                               <a:ea typeface="Calibri"/>
@@ -6272,7 +6988,7 @@
                             <a:t>DRUSEN </a:t>
                           </a:r>
                           <a:r>
-                            <a:rPr lang="en-US" sz="700">
+                            <a:rPr lang="en-US" sz="800" dirty="0">
                               <a:effectLst/>
                               <a:latin typeface="Calibri"/>
                               <a:ea typeface="Calibri"/>
@@ -6282,7 +6998,7 @@
                             <a:t></a:t>
                           </a:r>
                           <a:r>
-                            <a:rPr lang="fr-FR" sz="700">
+                            <a:rPr lang="fr-FR" sz="800" dirty="0">
                               <a:effectLst/>
                               <a:latin typeface="Calibri"/>
                               <a:ea typeface="Calibri"/>
@@ -6290,7 +7006,7 @@
                             </a:rPr>
                             <a:t> 0.992</a:t>
                           </a:r>
-                          <a:endParaRPr lang="el-GR" sz="1100">
+                          <a:endParaRPr lang="el-GR" sz="800" dirty="0">
                             <a:effectLst/>
                             <a:latin typeface="Calibri"/>
                             <a:ea typeface="Calibri"/>
@@ -6307,7 +7023,7 @@
                             </a:spcAft>
                           </a:pPr>
                           <a:r>
-                            <a:rPr lang="en-US" sz="800">
+                            <a:rPr lang="en-US" sz="800" dirty="0">
                               <a:effectLst/>
                               <a:latin typeface="Calibri"/>
                               <a:ea typeface="Calibri"/>
@@ -6316,7 +7032,7 @@
                             <a:t>NORMAL </a:t>
                           </a:r>
                           <a:r>
-                            <a:rPr lang="en-US" sz="700">
+                            <a:rPr lang="en-US" sz="800" dirty="0">
                               <a:effectLst/>
                               <a:latin typeface="Calibri"/>
                               <a:ea typeface="Calibri"/>
@@ -6326,7 +7042,7 @@
                             <a:t></a:t>
                           </a:r>
                           <a:r>
-                            <a:rPr lang="en-US" sz="700">
+                            <a:rPr lang="en-US" sz="800" dirty="0">
                               <a:effectLst/>
                               <a:latin typeface="Calibri"/>
                               <a:ea typeface="Calibri"/>
@@ -6334,7 +7050,7 @@
                             </a:rPr>
                             <a:t> 0.998</a:t>
                           </a:r>
-                          <a:endParaRPr lang="el-GR" sz="1100">
+                          <a:endParaRPr lang="el-GR" sz="800" dirty="0">
                             <a:effectLst/>
                             <a:latin typeface="Calibri"/>
                             <a:ea typeface="Calibri"/>
@@ -6447,7 +7163,7 @@
                         <a:t>CNV </a:t>
                       </a:r>
                       <a:r>
-                        <a:rPr lang="en-US" sz="700" dirty="0">
+                        <a:rPr lang="en-US" sz="800" dirty="0">
                           <a:solidFill>
                             <a:srgbClr val="FF0000"/>
                           </a:solidFill>
@@ -6460,7 +7176,7 @@
                         <a:t></a:t>
                       </a:r>
                       <a:r>
-                        <a:rPr lang="en-US" sz="700" dirty="0">
+                        <a:rPr lang="en-US" sz="800" dirty="0">
                           <a:solidFill>
                             <a:srgbClr val="FF0000"/>
                           </a:solidFill>
@@ -6471,7 +7187,7 @@
                         </a:rPr>
                         <a:t> 1.25%</a:t>
                       </a:r>
-                      <a:endParaRPr lang="el-GR" sz="1100" dirty="0">
+                      <a:endParaRPr lang="el-GR" sz="800" dirty="0">
                         <a:effectLst/>
                         <a:latin typeface="Calibri"/>
                         <a:ea typeface="Calibri"/>
@@ -6497,7 +7213,7 @@
                         <a:t>DME </a:t>
                       </a:r>
                       <a:r>
-                        <a:rPr lang="en-US" sz="700" dirty="0">
+                        <a:rPr lang="en-US" sz="800" dirty="0">
                           <a:effectLst/>
                           <a:latin typeface="Calibri"/>
                           <a:ea typeface="Calibri"/>
@@ -6507,7 +7223,7 @@
                         <a:t></a:t>
                       </a:r>
                       <a:r>
-                        <a:rPr lang="en-US" sz="700" dirty="0">
+                        <a:rPr lang="en-US" sz="800" dirty="0">
                           <a:effectLst/>
                           <a:latin typeface="Calibri"/>
                           <a:ea typeface="Calibri"/>
@@ -6516,7 +7232,7 @@
                         <a:t> </a:t>
                       </a:r>
                       <a:r>
-                        <a:rPr lang="fr-FR" sz="700" dirty="0">
+                        <a:rPr lang="fr-FR" sz="800" dirty="0">
                           <a:effectLst/>
                           <a:latin typeface="Calibri"/>
                           <a:ea typeface="Calibri"/>
@@ -6524,7 +7240,7 @@
                         </a:rPr>
                         <a:t>1.79%</a:t>
                       </a:r>
-                      <a:endParaRPr lang="el-GR" sz="1100" dirty="0">
+                      <a:endParaRPr lang="el-GR" sz="800" dirty="0">
                         <a:effectLst/>
                         <a:latin typeface="Calibri"/>
                         <a:ea typeface="Calibri"/>
@@ -6550,7 +7266,7 @@
                         <a:t>DRUSEN </a:t>
                       </a:r>
                       <a:r>
-                        <a:rPr lang="en-US" sz="700" dirty="0">
+                        <a:rPr lang="en-US" sz="800" dirty="0">
                           <a:effectLst/>
                           <a:latin typeface="Calibri"/>
                           <a:ea typeface="Calibri"/>
@@ -6560,7 +7276,7 @@
                         <a:t></a:t>
                       </a:r>
                       <a:r>
-                        <a:rPr lang="en-US" sz="700" dirty="0">
+                        <a:rPr lang="en-US" sz="800" dirty="0">
                           <a:effectLst/>
                           <a:latin typeface="Calibri"/>
                           <a:ea typeface="Calibri"/>
@@ -6569,7 +7285,7 @@
                         <a:t> </a:t>
                       </a:r>
                       <a:r>
-                        <a:rPr lang="fr-FR" sz="700" dirty="0">
+                        <a:rPr lang="fr-FR" sz="800" dirty="0">
                           <a:effectLst/>
                           <a:latin typeface="Calibri"/>
                           <a:ea typeface="Calibri"/>
@@ -6577,7 +7293,7 @@
                         </a:rPr>
                         <a:t>3.15%</a:t>
                       </a:r>
-                      <a:endParaRPr lang="el-GR" sz="1100" dirty="0">
+                      <a:endParaRPr lang="el-GR" sz="800" dirty="0">
                         <a:effectLst/>
                         <a:latin typeface="Calibri"/>
                         <a:ea typeface="Calibri"/>
@@ -6603,7 +7319,7 @@
                         <a:t>NORMAL </a:t>
                       </a:r>
                       <a:r>
-                        <a:rPr lang="en-US" sz="700" dirty="0">
+                        <a:rPr lang="en-US" sz="800" dirty="0">
                           <a:effectLst/>
                           <a:latin typeface="Calibri"/>
                           <a:ea typeface="Calibri"/>
@@ -6613,58 +7329,24 @@
                         <a:t></a:t>
                       </a:r>
                       <a:r>
-                        <a:rPr lang="en-US" sz="700" dirty="0">
+                        <a:rPr lang="en-US" sz="800" dirty="0">
                           <a:effectLst/>
                           <a:latin typeface="Calibri"/>
                           <a:ea typeface="Calibri"/>
                           <a:cs typeface="Arial"/>
                         </a:rPr>
-                        <a:t> 0.65%</a:t>
+                        <a:t> 0.65</a:t>
                       </a:r>
-                      <a:endParaRPr lang="el-GR" sz="1100" dirty="0">
-                        <a:effectLst/>
-                        <a:latin typeface="Calibri"/>
-                        <a:ea typeface="Calibri"/>
-                        <a:cs typeface="Arial"/>
-                      </a:endParaRPr>
-                    </a:p>
-                    <a:p>
-                      <a:pPr latinLnBrk="1">
-                        <a:lnSpc>
-                          <a:spcPct val="115000"/>
-                        </a:lnSpc>
-                        <a:spcAft>
-                          <a:spcPts val="0"/>
-                        </a:spcAft>
-                        <a:tabLst>
-                          <a:tab pos="581660" algn="l"/>
-                          <a:tab pos="1163320" algn="l"/>
-                          <a:tab pos="1744980" algn="l"/>
-                          <a:tab pos="2326640" algn="l"/>
-                          <a:tab pos="2908300" algn="l"/>
-                          <a:tab pos="3489960" algn="l"/>
-                          <a:tab pos="4071620" algn="l"/>
-                          <a:tab pos="4653280" algn="l"/>
-                          <a:tab pos="5234940" algn="l"/>
-                          <a:tab pos="5816600" algn="l"/>
-                          <a:tab pos="6398260" algn="l"/>
-                          <a:tab pos="6979920" algn="l"/>
-                          <a:tab pos="7561580" algn="l"/>
-                          <a:tab pos="8143240" algn="l"/>
-                          <a:tab pos="8724900" algn="l"/>
-                          <a:tab pos="9306560" algn="l"/>
-                        </a:tabLst>
-                      </a:pPr>
                       <a:r>
-                        <a:rPr lang="en-US" sz="1000" dirty="0">
+                        <a:rPr lang="en-US" sz="800" dirty="0" smtClean="0">
                           <a:effectLst/>
                           <a:latin typeface="Calibri"/>
                           <a:ea typeface="Calibri"/>
                           <a:cs typeface="Arial"/>
                         </a:rPr>
-                        <a:t> </a:t>
+                        <a:t>%</a:t>
                       </a:r>
-                      <a:endParaRPr lang="el-GR" sz="1100" dirty="0">
+                      <a:endParaRPr lang="el-GR" sz="800" dirty="0">
                         <a:effectLst/>
                         <a:latin typeface="Calibri"/>
                         <a:ea typeface="Calibri"/>
@@ -7132,7 +7814,7 @@
                             </a:spcAft>
                           </a:pPr>
                           <a:r>
-                            <a:rPr lang="fr-FR" sz="900" b="1" u="sng">
+                            <a:rPr lang="fr-FR" sz="900" b="1" u="sng" dirty="0">
                               <a:effectLst/>
                               <a:latin typeface="Calibri"/>
                               <a:ea typeface="Calibri"/>
@@ -7140,7 +7822,7 @@
                             </a:rPr>
                             <a:t>AUC values</a:t>
                           </a:r>
-                          <a:endParaRPr lang="el-GR" sz="1100">
+                          <a:endParaRPr lang="el-GR" sz="1100" dirty="0">
                             <a:effectLst/>
                             <a:latin typeface="Calibri"/>
                             <a:ea typeface="Calibri"/>
@@ -7157,7 +7839,7 @@
                             </a:spcAft>
                           </a:pPr>
                           <a:r>
-                            <a:rPr lang="fr-FR" sz="800">
+                            <a:rPr lang="fr-FR" sz="800" dirty="0">
                               <a:effectLst/>
                               <a:latin typeface="Calibri"/>
                               <a:ea typeface="Calibri"/>
@@ -7166,7 +7848,7 @@
                             <a:t>CNV </a:t>
                           </a:r>
                           <a:r>
-                            <a:rPr lang="en-US" sz="700">
+                            <a:rPr lang="en-US" sz="800" dirty="0">
                               <a:effectLst/>
                               <a:latin typeface="Calibri"/>
                               <a:ea typeface="Calibri"/>
@@ -7176,7 +7858,7 @@
                             <a:t></a:t>
                           </a:r>
                           <a:r>
-                            <a:rPr lang="fr-FR" sz="700">
+                            <a:rPr lang="fr-FR" sz="800" dirty="0">
                               <a:effectLst/>
                               <a:latin typeface="Calibri"/>
                               <a:ea typeface="Calibri"/>
@@ -7184,7 +7866,7 @@
                             </a:rPr>
                             <a:t> 0.998</a:t>
                           </a:r>
-                          <a:endParaRPr lang="el-GR" sz="1100">
+                          <a:endParaRPr lang="el-GR" sz="800" dirty="0">
                             <a:effectLst/>
                             <a:latin typeface="Calibri"/>
                             <a:ea typeface="Calibri"/>
@@ -7201,7 +7883,7 @@
                             </a:spcAft>
                           </a:pPr>
                           <a:r>
-                            <a:rPr lang="fr-FR" sz="800">
+                            <a:rPr lang="fr-FR" sz="800" dirty="0">
                               <a:effectLst/>
                               <a:latin typeface="Calibri"/>
                               <a:ea typeface="Calibri"/>
@@ -7210,7 +7892,7 @@
                             <a:t>DME </a:t>
                           </a:r>
                           <a:r>
-                            <a:rPr lang="en-US" sz="700">
+                            <a:rPr lang="en-US" sz="800" dirty="0">
                               <a:effectLst/>
                               <a:latin typeface="Calibri"/>
                               <a:ea typeface="Calibri"/>
@@ -7220,7 +7902,7 @@
                             <a:t></a:t>
                           </a:r>
                           <a:r>
-                            <a:rPr lang="fr-FR" sz="700">
+                            <a:rPr lang="fr-FR" sz="800" dirty="0">
                               <a:effectLst/>
                               <a:latin typeface="Calibri"/>
                               <a:ea typeface="Calibri"/>
@@ -7228,7 +7910,7 @@
                             </a:rPr>
                             <a:t> 0.996</a:t>
                           </a:r>
-                          <a:endParaRPr lang="el-GR" sz="1100">
+                          <a:endParaRPr lang="el-GR" sz="800" dirty="0">
                             <a:effectLst/>
                             <a:latin typeface="Calibri"/>
                             <a:ea typeface="Calibri"/>
@@ -7245,7 +7927,7 @@
                             </a:spcAft>
                           </a:pPr>
                           <a:r>
-                            <a:rPr lang="fr-FR" sz="800">
+                            <a:rPr lang="fr-FR" sz="800" dirty="0">
                               <a:effectLst/>
                               <a:latin typeface="Calibri"/>
                               <a:ea typeface="Calibri"/>
@@ -7254,7 +7936,7 @@
                             <a:t>DRUSEN </a:t>
                           </a:r>
                           <a:r>
-                            <a:rPr lang="en-US" sz="700">
+                            <a:rPr lang="en-US" sz="800" dirty="0">
                               <a:effectLst/>
                               <a:latin typeface="Calibri"/>
                               <a:ea typeface="Calibri"/>
@@ -7264,7 +7946,7 @@
                             <a:t></a:t>
                           </a:r>
                           <a:r>
-                            <a:rPr lang="fr-FR" sz="700">
+                            <a:rPr lang="fr-FR" sz="800" dirty="0">
                               <a:effectLst/>
                               <a:latin typeface="Calibri"/>
                               <a:ea typeface="Calibri"/>
@@ -7272,7 +7954,7 @@
                             </a:rPr>
                             <a:t> 0.990</a:t>
                           </a:r>
-                          <a:endParaRPr lang="el-GR" sz="1100">
+                          <a:endParaRPr lang="el-GR" sz="800" dirty="0">
                             <a:effectLst/>
                             <a:latin typeface="Calibri"/>
                             <a:ea typeface="Calibri"/>
@@ -7289,7 +7971,7 @@
                             </a:spcAft>
                           </a:pPr>
                           <a:r>
-                            <a:rPr lang="en-US" sz="800">
+                            <a:rPr lang="en-US" sz="800" dirty="0">
                               <a:effectLst/>
                               <a:latin typeface="Calibri"/>
                               <a:ea typeface="Calibri"/>
@@ -7298,7 +7980,7 @@
                             <a:t>NORMAL </a:t>
                           </a:r>
                           <a:r>
-                            <a:rPr lang="en-US" sz="700">
+                            <a:rPr lang="en-US" sz="800" dirty="0">
                               <a:effectLst/>
                               <a:latin typeface="Calibri"/>
                               <a:ea typeface="Calibri"/>
@@ -7308,7 +7990,7 @@
                             <a:t></a:t>
                           </a:r>
                           <a:r>
-                            <a:rPr lang="en-US" sz="700">
+                            <a:rPr lang="en-US" sz="800" dirty="0">
                               <a:effectLst/>
                               <a:latin typeface="Calibri"/>
                               <a:ea typeface="Calibri"/>
@@ -7316,7 +7998,7 @@
                             </a:rPr>
                             <a:t> 0.998</a:t>
                           </a:r>
-                          <a:endParaRPr lang="el-GR" sz="1100">
+                          <a:endParaRPr lang="el-GR" sz="800" dirty="0">
                             <a:effectLst/>
                             <a:latin typeface="Calibri"/>
                             <a:ea typeface="Calibri"/>
@@ -7456,7 +8138,7 @@
                   </a:spcAft>
                 </a:pPr>
                 <a:r>
-                  <a:rPr lang="fr-FR" sz="800">
+                  <a:rPr lang="fr-FR" sz="800" dirty="0">
                     <a:effectLst/>
                     <a:latin typeface="Calibri"/>
                     <a:ea typeface="Calibri"/>
@@ -7465,7 +8147,7 @@
                   <a:t>CNV </a:t>
                 </a:r>
                 <a:r>
-                  <a:rPr lang="en-US" sz="700">
+                  <a:rPr lang="en-US" sz="700" dirty="0">
                     <a:effectLst/>
                     <a:latin typeface="Calibri"/>
                     <a:ea typeface="Calibri"/>
@@ -7475,7 +8157,7 @@
                   <a:t></a:t>
                 </a:r>
                 <a:r>
-                  <a:rPr lang="en-US" sz="800">
+                  <a:rPr lang="en-US" sz="800" dirty="0">
                     <a:effectLst/>
                     <a:latin typeface="Calibri"/>
                     <a:ea typeface="Calibri"/>
@@ -7484,7 +8166,7 @@
                   <a:t> </a:t>
                 </a:r>
                 <a:r>
-                  <a:rPr lang="fr-FR" sz="800">
+                  <a:rPr lang="fr-FR" sz="800" dirty="0">
                     <a:effectLst/>
                     <a:latin typeface="Calibri"/>
                     <a:ea typeface="Calibri"/>
@@ -7492,7 +8174,7 @@
                   </a:rPr>
                   <a:t>0.62%</a:t>
                 </a:r>
-                <a:endParaRPr lang="el-GR" sz="1100">
+                <a:endParaRPr lang="el-GR" sz="1100" dirty="0">
                   <a:effectLst/>
                   <a:latin typeface="Calibri"/>
                   <a:ea typeface="Calibri"/>
@@ -7509,7 +8191,7 @@
                   </a:spcAft>
                 </a:pPr>
                 <a:r>
-                  <a:rPr lang="fr-FR" sz="800">
+                  <a:rPr lang="fr-FR" sz="800" dirty="0">
                     <a:effectLst/>
                     <a:latin typeface="Calibri"/>
                     <a:ea typeface="Calibri"/>
@@ -7518,7 +8200,7 @@
                   <a:t>DME </a:t>
                 </a:r>
                 <a:r>
-                  <a:rPr lang="en-US" sz="700">
+                  <a:rPr lang="en-US" sz="700" dirty="0">
                     <a:effectLst/>
                     <a:latin typeface="Calibri"/>
                     <a:ea typeface="Calibri"/>
@@ -7528,7 +8210,7 @@
                   <a:t></a:t>
                 </a:r>
                 <a:r>
-                  <a:rPr lang="en-US" sz="700">
+                  <a:rPr lang="en-US" sz="700" dirty="0">
                     <a:effectLst/>
                     <a:latin typeface="Calibri"/>
                     <a:ea typeface="Calibri"/>
@@ -7537,7 +8219,7 @@
                   <a:t> </a:t>
                 </a:r>
                 <a:r>
-                  <a:rPr lang="fr-FR" sz="700">
+                  <a:rPr lang="fr-FR" sz="800" dirty="0">
                     <a:effectLst/>
                     <a:latin typeface="Calibri"/>
                     <a:ea typeface="Calibri"/>
@@ -7545,7 +8227,7 @@
                   </a:rPr>
                   <a:t>1.53%</a:t>
                 </a:r>
-                <a:endParaRPr lang="el-GR" sz="1100">
+                <a:endParaRPr lang="el-GR" sz="800" dirty="0">
                   <a:effectLst/>
                   <a:latin typeface="Calibri"/>
                   <a:ea typeface="Calibri"/>
@@ -7562,7 +8244,7 @@
                   </a:spcAft>
                 </a:pPr>
                 <a:r>
-                  <a:rPr lang="fr-FR" sz="800">
+                  <a:rPr lang="fr-FR" sz="800" dirty="0">
                     <a:effectLst/>
                     <a:latin typeface="Calibri"/>
                     <a:ea typeface="Calibri"/>
@@ -7571,7 +8253,7 @@
                   <a:t>DRUSEN </a:t>
                 </a:r>
                 <a:r>
-                  <a:rPr lang="en-US" sz="700">
+                  <a:rPr lang="en-US" sz="700" dirty="0">
                     <a:effectLst/>
                     <a:latin typeface="Calibri"/>
                     <a:ea typeface="Calibri"/>
@@ -7581,7 +8263,7 @@
                   <a:t></a:t>
                 </a:r>
                 <a:r>
-                  <a:rPr lang="en-US" sz="700">
+                  <a:rPr lang="en-US" sz="700" dirty="0">
                     <a:effectLst/>
                     <a:latin typeface="Calibri"/>
                     <a:ea typeface="Calibri"/>
@@ -7590,7 +8272,7 @@
                   <a:t> </a:t>
                 </a:r>
                 <a:r>
-                  <a:rPr lang="fr-FR" sz="700">
+                  <a:rPr lang="fr-FR" sz="800" dirty="0">
                     <a:effectLst/>
                     <a:latin typeface="Calibri"/>
                     <a:ea typeface="Calibri"/>
@@ -7598,7 +8280,7 @@
                   </a:rPr>
                   <a:t>3.73%</a:t>
                 </a:r>
-                <a:endParaRPr lang="el-GR" sz="1100">
+                <a:endParaRPr lang="el-GR" sz="800" dirty="0">
                   <a:effectLst/>
                   <a:latin typeface="Calibri"/>
                   <a:ea typeface="Calibri"/>
@@ -7615,7 +8297,7 @@
                   </a:spcAft>
                 </a:pPr>
                 <a:r>
-                  <a:rPr lang="en-US" sz="800">
+                  <a:rPr lang="en-US" sz="800" dirty="0">
                     <a:effectLst/>
                     <a:latin typeface="Calibri"/>
                     <a:ea typeface="Calibri"/>
@@ -7624,7 +8306,7 @@
                   <a:t>NORMAL </a:t>
                 </a:r>
                 <a:r>
-                  <a:rPr lang="en-US" sz="700">
+                  <a:rPr lang="en-US" sz="700" dirty="0">
                     <a:effectLst/>
                     <a:latin typeface="Calibri"/>
                     <a:ea typeface="Calibri"/>
@@ -7634,15 +8316,24 @@
                   <a:t></a:t>
                 </a:r>
                 <a:r>
-                  <a:rPr lang="en-US" sz="700">
+                  <a:rPr lang="en-US" sz="700" dirty="0">
                     <a:effectLst/>
                     <a:latin typeface="Calibri"/>
                     <a:ea typeface="Calibri"/>
                     <a:cs typeface="Arial"/>
                   </a:rPr>
-                  <a:t> 0.25%</a:t>
+                  <a:t> </a:t>
                 </a:r>
-                <a:endParaRPr lang="el-GR" sz="1100">
+                <a:r>
+                  <a:rPr lang="en-US" sz="800" dirty="0">
+                    <a:effectLst/>
+                    <a:latin typeface="Calibri"/>
+                    <a:ea typeface="Calibri"/>
+                    <a:cs typeface="Arial"/>
+                  </a:rPr>
+                  <a:t>0.25%</a:t>
+                </a:r>
+                <a:endParaRPr lang="el-GR" sz="800" dirty="0">
                   <a:effectLst/>
                   <a:latin typeface="Calibri"/>
                   <a:ea typeface="Calibri"/>
@@ -7677,7 +8368,7 @@
                   </a:tabLst>
                 </a:pPr>
                 <a:r>
-                  <a:rPr lang="en-US" sz="1000">
+                  <a:rPr lang="en-US" sz="1000" dirty="0">
                     <a:effectLst/>
                     <a:latin typeface="Calibri"/>
                     <a:ea typeface="Calibri"/>
@@ -7685,7 +8376,7 @@
                   </a:rPr>
                   <a:t> </a:t>
                 </a:r>
-                <a:endParaRPr lang="el-GR" sz="1100">
+                <a:endParaRPr lang="el-GR" sz="1100" dirty="0">
                   <a:effectLst/>
                   <a:latin typeface="Calibri"/>
                   <a:ea typeface="Calibri"/>
@@ -7746,8 +8437,8 @@
         </p:nvSpPr>
         <p:spPr>
           <a:xfrm>
-            <a:off x="457200" y="22860"/>
-            <a:ext cx="8229600" cy="739140"/>
+            <a:off x="89917" y="22860"/>
+            <a:ext cx="8892409" cy="739140"/>
           </a:xfrm>
         </p:spPr>
         <p:txBody>
@@ -7758,7 +8449,19 @@
           <a:p>
             <a:r>
               <a:rPr lang="en-US" sz="2400" b="1" dirty="0"/>
-              <a:t>Effects of Class-specific refinement and Temperature Scaling</a:t>
+              <a:t>Effects of </a:t>
+            </a:r>
+            <a:r>
+              <a:rPr lang="en-US" sz="2400" b="1" dirty="0" smtClean="0"/>
+              <a:t>“Class-Specific Refinement” </a:t>
+            </a:r>
+            <a:r>
+              <a:rPr lang="en-US" sz="2400" b="1" dirty="0"/>
+              <a:t>and </a:t>
+            </a:r>
+            <a:r>
+              <a:rPr lang="en-US" sz="2400" b="1" dirty="0" smtClean="0"/>
+              <a:t>“Temperature Scaling”</a:t>
             </a:r>
             <a:endParaRPr lang="el-GR" sz="2400" b="1" dirty="0"/>
           </a:p>
@@ -7772,8 +8475,8 @@
         </p:nvSpPr>
         <p:spPr>
           <a:xfrm>
-            <a:off x="76200" y="3810000"/>
-            <a:ext cx="2696494" cy="2923877"/>
+            <a:off x="76200" y="3657600"/>
+            <a:ext cx="2696494" cy="2446824"/>
           </a:xfrm>
           <a:prstGeom prst="rect">
             <a:avLst/>
@@ -7819,8 +8522,12 @@
               <a:t>Apart from </a:t>
             </a:r>
             <a:r>
+              <a:rPr lang="en-US" sz="1200" b="1" dirty="0" smtClean="0"/>
+              <a:t>Augmentation</a:t>
+            </a:r>
+            <a:r>
               <a:rPr lang="en-US" sz="1200" b="1" dirty="0"/>
-              <a:t>Data augmentation: </a:t>
+              <a:t>: </a:t>
             </a:r>
           </a:p>
           <a:p>
@@ -7835,8 +8542,33 @@
             </a:r>
             <a:r>
               <a:rPr lang="en-US" sz="1200" dirty="0"/>
-              <a:t>reduced the final test set high-confidence error count to 158</a:t>
-            </a:r>
+              <a:t>and</a:t>
+            </a:r>
+            <a:r>
+              <a:rPr lang="en-US" sz="1200" b="1" dirty="0"/>
+              <a:t> Temperature scaling </a:t>
+            </a:r>
+            <a:r>
+              <a:rPr lang="en-US" sz="1200" dirty="0" smtClean="0"/>
+              <a:t>reduced </a:t>
+            </a:r>
+            <a:r>
+              <a:rPr lang="en-US" sz="1200" dirty="0"/>
+              <a:t>the final test set high-confidence error count </a:t>
+            </a:r>
+            <a:r>
+              <a:rPr lang="en-US" sz="1200" dirty="0" smtClean="0"/>
+              <a:t>down to 158 (by </a:t>
+            </a:r>
+            <a:r>
+              <a:rPr lang="en-US" sz="1200" dirty="0"/>
+              <a:t>28.8</a:t>
+            </a:r>
+            <a:r>
+              <a:rPr lang="en-US" sz="1200" dirty="0" smtClean="0"/>
+              <a:t>%).</a:t>
+            </a:r>
+            <a:endParaRPr lang="en-US" sz="1200" dirty="0"/>
           </a:p>
           <a:p>
             <a:pPr algn="just"/>
@@ -7844,28 +8576,45 @@
           </a:p>
           <a:p>
             <a:pPr algn="just"/>
-            <a:r>
-              <a:rPr lang="en-US" sz="1200" b="1" dirty="0"/>
-              <a:t>Temperature scaling </a:t>
-            </a:r>
-            <a:r>
-              <a:rPr lang="en-US" sz="1200" dirty="0"/>
-              <a:t>substantially reduced high-confidence false predictions (misclassifications) by 28.8%</a:t>
-            </a:r>
+            <a:endParaRPr lang="en-US" sz="1200" dirty="0" smtClean="0">
+              <a:solidFill>
+                <a:srgbClr val="C00000"/>
+              </a:solidFill>
+            </a:endParaRPr>
           </a:p>
           <a:p>
             <a:pPr algn="just"/>
-            <a:endParaRPr lang="en-US" sz="700" dirty="0"/>
-          </a:p>
-          <a:p>
-            <a:pPr algn="just"/>
+            <a:r>
+              <a:rPr lang="en-US" sz="1200" dirty="0" smtClean="0">
+                <a:solidFill>
+                  <a:srgbClr val="C00000"/>
+                </a:solidFill>
+              </a:rPr>
+              <a:t>This </a:t>
+            </a:r>
             <a:r>
               <a:rPr lang="en-US" sz="1200" dirty="0">
                 <a:solidFill>
                   <a:srgbClr val="C00000"/>
                 </a:solidFill>
               </a:rPr>
-              <a:t>This refinement is important in medical diagnostic applications, where erroneous high-confidence predictions may directly impact clinical decision-making.</a:t>
+              <a:t>refinement is important in medical diagnostic applications, </a:t>
+            </a:r>
+            <a:r>
+              <a:rPr lang="en-US" sz="1200" dirty="0" smtClean="0">
+                <a:solidFill>
+                  <a:srgbClr val="C00000"/>
+                </a:solidFill>
+              </a:rPr>
+              <a:t>as erroneous </a:t>
+            </a:r>
+            <a:r>
+              <a:rPr lang="en-US" sz="1200" dirty="0">
+                <a:solidFill>
+                  <a:srgbClr val="C00000"/>
+                </a:solidFill>
+              </a:rPr>
+              <a:t>high-confidence predictions may directly impact clinical decision-making.</a:t>
             </a:r>
             <a:endParaRPr lang="el-GR" sz="1200" dirty="0">
               <a:solidFill>
@@ -7883,8 +8632,8 @@
         </p:nvSpPr>
         <p:spPr>
           <a:xfrm>
-            <a:off x="76200" y="609600"/>
-            <a:ext cx="2696494" cy="2385268"/>
+            <a:off x="76200" y="759529"/>
+            <a:ext cx="2696494" cy="1831271"/>
           </a:xfrm>
           <a:prstGeom prst="rect">
             <a:avLst/>
@@ -7964,72 +8713,6 @@
           <a:p>
             <a:pPr algn="just"/>
             <a:endParaRPr lang="en-US" sz="1200" dirty="0"/>
-          </a:p>
-          <a:p>
-            <a:pPr algn="just"/>
-            <a:r>
-              <a:rPr lang="en-US" sz="1200" dirty="0"/>
-              <a:t>Total misclassifications for test set above threshold were </a:t>
-            </a:r>
-            <a:r>
-              <a:rPr lang="en-US" sz="1200" u="sng" dirty="0"/>
-              <a:t>only 222</a:t>
-            </a:r>
-            <a:r>
-              <a:rPr lang="en-US" sz="1200" dirty="0"/>
-              <a:t> out of 16,699 samples (1.3%). </a:t>
-            </a:r>
-            <a:endParaRPr lang="en-US" sz="700" dirty="0"/>
-          </a:p>
-        </p:txBody>
-      </p:sp>
-      <p:sp>
-        <p:nvSpPr>
-          <p:cNvPr id="4" name="Rectangle 3"/>
-          <p:cNvSpPr/>
-          <p:nvPr/>
-        </p:nvSpPr>
-        <p:spPr>
-          <a:xfrm>
-            <a:off x="89917" y="3048000"/>
-            <a:ext cx="2805683" cy="646331"/>
-          </a:xfrm>
-          <a:prstGeom prst="rect">
-            <a:avLst/>
-          </a:prstGeom>
-        </p:spPr>
-        <p:txBody>
-          <a:bodyPr wrap="square">
-            <a:spAutoFit/>
-          </a:bodyPr>
-          <a:lstStyle/>
-          <a:p>
-            <a:pPr algn="just"/>
-            <a:r>
-              <a:rPr lang="en-US" sz="1200" dirty="0"/>
-              <a:t>*Hard-case mining revealed </a:t>
-            </a:r>
-            <a:r>
-              <a:rPr lang="en-US" sz="1200" dirty="0">
-                <a:solidFill>
-                  <a:srgbClr val="FF0000"/>
-                </a:solidFill>
-              </a:rPr>
-              <a:t>327 high-confidence misclassifications within the training set</a:t>
-            </a:r>
-            <a:r>
-              <a:rPr lang="en-US" sz="1200" dirty="0"/>
-              <a:t>, mainly for CNV and </a:t>
-            </a:r>
-            <a:r>
-              <a:rPr lang="en-US" sz="1200" dirty="0" err="1"/>
-              <a:t>Drusen</a:t>
-            </a:r>
-            <a:r>
-              <a:rPr lang="en-US" sz="1200" dirty="0"/>
-              <a:t>.</a:t>
-            </a:r>
-            <a:endParaRPr lang="el-GR" sz="1200" dirty="0"/>
           </a:p>
         </p:txBody>
       </p:sp>
@@ -8091,42 +8774,42 @@
                 <a:gridCol w="1160868">
                   <a:extLst>
                     <a:ext uri="{9D8B030D-6E8A-4147-A177-3AD203B41FA5}">
-                      <a16:colId xmlns:a16="http://schemas.microsoft.com/office/drawing/2014/main" val="20000"/>
+                      <a16:colId xmlns:a16="http://schemas.microsoft.com/office/drawing/2014/main" xmlns="" val="20000"/>
                     </a:ext>
                   </a:extLst>
                 </a:gridCol>
                 <a:gridCol w="892171">
                   <a:extLst>
                     <a:ext uri="{9D8B030D-6E8A-4147-A177-3AD203B41FA5}">
-                      <a16:colId xmlns:a16="http://schemas.microsoft.com/office/drawing/2014/main" val="20001"/>
+                      <a16:colId xmlns:a16="http://schemas.microsoft.com/office/drawing/2014/main" xmlns="" val="20001"/>
                     </a:ext>
                   </a:extLst>
                 </a:gridCol>
                 <a:gridCol w="917110">
                   <a:extLst>
                     <a:ext uri="{9D8B030D-6E8A-4147-A177-3AD203B41FA5}">
-                      <a16:colId xmlns:a16="http://schemas.microsoft.com/office/drawing/2014/main" val="20002"/>
+                      <a16:colId xmlns:a16="http://schemas.microsoft.com/office/drawing/2014/main" xmlns="" val="20002"/>
                     </a:ext>
                   </a:extLst>
                 </a:gridCol>
                 <a:gridCol w="917110">
                   <a:extLst>
                     <a:ext uri="{9D8B030D-6E8A-4147-A177-3AD203B41FA5}">
-                      <a16:colId xmlns:a16="http://schemas.microsoft.com/office/drawing/2014/main" val="20003"/>
+                      <a16:colId xmlns:a16="http://schemas.microsoft.com/office/drawing/2014/main" xmlns="" val="20003"/>
                     </a:ext>
                   </a:extLst>
                 </a:gridCol>
                 <a:gridCol w="917110">
                   <a:extLst>
                     <a:ext uri="{9D8B030D-6E8A-4147-A177-3AD203B41FA5}">
-                      <a16:colId xmlns:a16="http://schemas.microsoft.com/office/drawing/2014/main" val="20004"/>
+                      <a16:colId xmlns:a16="http://schemas.microsoft.com/office/drawing/2014/main" xmlns="" val="20004"/>
                     </a:ext>
                   </a:extLst>
                 </a:gridCol>
                 <a:gridCol w="1026519">
                   <a:extLst>
                     <a:ext uri="{9D8B030D-6E8A-4147-A177-3AD203B41FA5}">
-                      <a16:colId xmlns:a16="http://schemas.microsoft.com/office/drawing/2014/main" val="20005"/>
+                      <a16:colId xmlns:a16="http://schemas.microsoft.com/office/drawing/2014/main" xmlns="" val="20005"/>
                     </a:ext>
                   </a:extLst>
                 </a:gridCol>
@@ -8251,7 +8934,7 @@
                 </a:tc>
                 <a:extLst>
                   <a:ext uri="{0D108BD9-81ED-4DB2-BD59-A6C34878D82A}">
-                    <a16:rowId xmlns:a16="http://schemas.microsoft.com/office/drawing/2014/main" val="10000"/>
+                    <a16:rowId xmlns:a16="http://schemas.microsoft.com/office/drawing/2014/main" xmlns="" val="10000"/>
                   </a:ext>
                 </a:extLst>
               </a:tr>
@@ -8451,7 +9134,7 @@
                 </a:tc>
                 <a:extLst>
                   <a:ext uri="{0D108BD9-81ED-4DB2-BD59-A6C34878D82A}">
-                    <a16:rowId xmlns:a16="http://schemas.microsoft.com/office/drawing/2014/main" val="10001"/>
+                    <a16:rowId xmlns:a16="http://schemas.microsoft.com/office/drawing/2014/main" xmlns="" val="10001"/>
                   </a:ext>
                 </a:extLst>
               </a:tr>
@@ -8632,7 +9315,7 @@
                 </a:tc>
                 <a:extLst>
                   <a:ext uri="{0D108BD9-81ED-4DB2-BD59-A6C34878D82A}">
-                    <a16:rowId xmlns:a16="http://schemas.microsoft.com/office/drawing/2014/main" val="10002"/>
+                    <a16:rowId xmlns:a16="http://schemas.microsoft.com/office/drawing/2014/main" xmlns="" val="10002"/>
                   </a:ext>
                 </a:extLst>
               </a:tr>
@@ -8813,7 +9496,7 @@
                 </a:tc>
                 <a:extLst>
                   <a:ext uri="{0D108BD9-81ED-4DB2-BD59-A6C34878D82A}">
-                    <a16:rowId xmlns:a16="http://schemas.microsoft.com/office/drawing/2014/main" val="10003"/>
+                    <a16:rowId xmlns:a16="http://schemas.microsoft.com/office/drawing/2014/main" xmlns="" val="10003"/>
                   </a:ext>
                 </a:extLst>
               </a:tr>
@@ -8994,7 +9677,7 @@
                 </a:tc>
                 <a:extLst>
                   <a:ext uri="{0D108BD9-81ED-4DB2-BD59-A6C34878D82A}">
-                    <a16:rowId xmlns:a16="http://schemas.microsoft.com/office/drawing/2014/main" val="10004"/>
+                    <a16:rowId xmlns:a16="http://schemas.microsoft.com/office/drawing/2014/main" xmlns="" val="10004"/>
                   </a:ext>
                 </a:extLst>
               </a:tr>
@@ -9175,7 +9858,7 @@
                 </a:tc>
                 <a:extLst>
                   <a:ext uri="{0D108BD9-81ED-4DB2-BD59-A6C34878D82A}">
-                    <a16:rowId xmlns:a16="http://schemas.microsoft.com/office/drawing/2014/main" val="10005"/>
+                    <a16:rowId xmlns:a16="http://schemas.microsoft.com/office/drawing/2014/main" xmlns="" val="10005"/>
                   </a:ext>
                 </a:extLst>
               </a:tr>
@@ -9356,7 +10039,7 @@
                 </a:tc>
                 <a:extLst>
                   <a:ext uri="{0D108BD9-81ED-4DB2-BD59-A6C34878D82A}">
-                    <a16:rowId xmlns:a16="http://schemas.microsoft.com/office/drawing/2014/main" val="10006"/>
+                    <a16:rowId xmlns:a16="http://schemas.microsoft.com/office/drawing/2014/main" xmlns="" val="10006"/>
                   </a:ext>
                 </a:extLst>
               </a:tr>
@@ -9537,7 +10220,7 @@
                 </a:tc>
                 <a:extLst>
                   <a:ext uri="{0D108BD9-81ED-4DB2-BD59-A6C34878D82A}">
-                    <a16:rowId xmlns:a16="http://schemas.microsoft.com/office/drawing/2014/main" val="10007"/>
+                    <a16:rowId xmlns:a16="http://schemas.microsoft.com/office/drawing/2014/main" xmlns="" val="10007"/>
                   </a:ext>
                 </a:extLst>
               </a:tr>
@@ -10719,7 +11402,7 @@
           <p:cNvPr id="4" name="TextBox 3">
             <a:extLst>
               <a:ext uri="{FF2B5EF4-FFF2-40B4-BE49-F238E27FC236}">
-                <a16:creationId xmlns:a16="http://schemas.microsoft.com/office/drawing/2014/main" id="{DD023DB0-311E-382C-8BD4-7970782DE5D5}"/>
+                <a16:creationId xmlns:a16="http://schemas.microsoft.com/office/drawing/2014/main" xmlns="" id="{DD023DB0-311E-382C-8BD4-7970782DE5D5}"/>
               </a:ext>
             </a:extLst>
           </p:cNvPr>
@@ -10728,8 +11411,48 @@
         </p:nvSpPr>
         <p:spPr>
           <a:xfrm>
-            <a:off x="2052336" y="228600"/>
-            <a:ext cx="5039328" cy="461665"/>
+            <a:off x="304801" y="228600"/>
+            <a:ext cx="8534400" cy="461665"/>
+          </a:xfrm>
+          <a:prstGeom prst="rect">
+            <a:avLst/>
+          </a:prstGeom>
+          <a:noFill/>
+        </p:spPr>
+        <p:txBody>
+          <a:bodyPr wrap="square" rtlCol="0">
+            <a:spAutoFit/>
+          </a:bodyPr>
+          <a:lstStyle/>
+          <a:p>
+            <a:pPr algn="ctr"/>
+            <a:r>
+              <a:rPr lang="x-none" sz="2400" b="1" smtClean="0"/>
+              <a:t>Interpretability </a:t>
+            </a:r>
+            <a:r>
+              <a:rPr lang="x-none" sz="2400" b="1" dirty="0"/>
+              <a:t>– Occlusion Sensitivity</a:t>
+            </a:r>
+          </a:p>
+        </p:txBody>
+      </p:sp>
+      <p:sp>
+        <p:nvSpPr>
+          <p:cNvPr id="9" name="TextBox 8">
+            <a:extLst>
+              <a:ext uri="{FF2B5EF4-FFF2-40B4-BE49-F238E27FC236}">
+                <a16:creationId xmlns:a16="http://schemas.microsoft.com/office/drawing/2014/main" xmlns="" id="{4DA6F5A9-D1BA-7871-338F-AB21A580E37A}"/>
+              </a:ext>
+            </a:extLst>
+          </p:cNvPr>
+          <p:cNvSpPr txBox="1"/>
+          <p:nvPr/>
+        </p:nvSpPr>
+        <p:spPr>
+          <a:xfrm>
+            <a:off x="946198" y="4812268"/>
+            <a:ext cx="2562368" cy="369332"/>
           </a:xfrm>
           <a:prstGeom prst="rect">
             <a:avLst/>
@@ -10743,23 +11466,108 @@
           <a:lstStyle/>
           <a:p>
             <a:r>
-              <a:rPr lang="en-GR" sz="2400" b="1" dirty="0"/>
-              <a:t>Interpretability – Occlusion Sensitivity</a:t>
-            </a:r>
+              <a:rPr lang="x-none" dirty="0">
+                <a:solidFill>
+                  <a:srgbClr val="FF0000"/>
+                </a:solidFill>
+              </a:rPr>
+              <a:t>Also captures some noise</a:t>
+            </a:r>
+          </a:p>
+        </p:txBody>
+      </p:sp>
+      <p:sp>
+        <p:nvSpPr>
+          <p:cNvPr id="2" name="Rectangle 1"/>
+          <p:cNvSpPr/>
+          <p:nvPr/>
+        </p:nvSpPr>
+        <p:spPr>
+          <a:xfrm>
+            <a:off x="76200" y="1197428"/>
+            <a:ext cx="4876800" cy="2462213"/>
+          </a:xfrm>
+          <a:prstGeom prst="rect">
+            <a:avLst/>
+          </a:prstGeom>
+        </p:spPr>
+        <p:txBody>
+          <a:bodyPr wrap="square">
+            <a:spAutoFit/>
+          </a:bodyPr>
+          <a:lstStyle/>
+          <a:p>
+            <a:r>
+              <a:rPr lang="en-US" sz="1400" b="1" dirty="0"/>
+              <a:t>Occlusion Sensitivity </a:t>
+            </a:r>
+            <a:r>
+              <a:rPr lang="en-US" sz="1400" dirty="0" smtClean="0"/>
+              <a:t>technique is used </a:t>
+            </a:r>
+            <a:r>
+              <a:rPr lang="en-US" sz="1400" dirty="0"/>
+              <a:t>to understand how a CNN makes decisions</a:t>
+            </a:r>
+            <a:r>
+              <a:rPr lang="en-US" sz="1400" dirty="0" smtClean="0"/>
+              <a:t>.</a:t>
+            </a:r>
+          </a:p>
+          <a:p>
+            <a:endParaRPr lang="en-US" sz="1400" dirty="0"/>
+          </a:p>
+          <a:p>
+            <a:r>
+              <a:rPr lang="en-US" sz="1400" dirty="0" smtClean="0"/>
+              <a:t>Works </a:t>
+            </a:r>
+            <a:r>
+              <a:rPr lang="en-US" sz="1400" dirty="0"/>
+              <a:t>by covering (occluding) small parts of an input image and observing how the model’s prediction changes</a:t>
+            </a:r>
+            <a:r>
+              <a:rPr lang="en-US" sz="1400" dirty="0" smtClean="0"/>
+              <a:t>.</a:t>
+            </a:r>
+          </a:p>
+          <a:p>
+            <a:endParaRPr lang="en-US" sz="1400" dirty="0"/>
+          </a:p>
+          <a:p>
+            <a:r>
+              <a:rPr lang="en-US" sz="1400" dirty="0"/>
+              <a:t>If blocking a region causes a large drop in confidence, that region is important for the decision</a:t>
+            </a:r>
+            <a:r>
+              <a:rPr lang="en-US" sz="1400" dirty="0" smtClean="0"/>
+              <a:t>.</a:t>
+            </a:r>
+          </a:p>
+          <a:p>
+            <a:endParaRPr lang="en-US" sz="1400" dirty="0"/>
+          </a:p>
+          <a:p>
+            <a:endParaRPr lang="en-US" sz="1400" dirty="0" smtClean="0"/>
+          </a:p>
+          <a:p>
+            <a:r>
+              <a:rPr lang="en-US" sz="1400" b="1" dirty="0"/>
+              <a:t>Hide part → Check prediction change → Measure importance</a:t>
+            </a:r>
+            <a:r>
+              <a:rPr lang="en-US" sz="1400" dirty="0"/>
+              <a:t>.</a:t>
+            </a:r>
+            <a:endParaRPr lang="el-GR" sz="1400" dirty="0"/>
           </a:p>
         </p:txBody>
       </p:sp>
       <p:pic>
         <p:nvPicPr>
-          <p:cNvPr id="6" name="Picture 5">
-            <a:extLst>
-              <a:ext uri="{FF2B5EF4-FFF2-40B4-BE49-F238E27FC236}">
-                <a16:creationId xmlns:a16="http://schemas.microsoft.com/office/drawing/2014/main" id="{9E583587-951B-7A5D-99BB-F028C7485DA8}"/>
-              </a:ext>
-            </a:extLst>
-          </p:cNvPr>
+          <p:cNvPr id="1026" name="Picture 2" descr="C:\Users\PC\Downloads\occlusion.png"/>
           <p:cNvPicPr>
-            <a:picLocks noChangeAspect="1"/>
+            <a:picLocks noChangeAspect="1" noChangeArrowheads="1"/>
           </p:cNvPicPr>
           <p:nvPr/>
         </p:nvPicPr>
@@ -10771,26 +11579,37 @@
               </a:ext>
             </a:extLst>
           </a:blip>
+          <a:srcRect/>
           <a:stretch>
             <a:fillRect/>
           </a:stretch>
         </p:blipFill>
-        <p:spPr>
+        <p:spPr bwMode="auto">
           <a:xfrm>
-            <a:off x="4343400" y="1295400"/>
-            <a:ext cx="4318000" cy="4813300"/>
+            <a:off x="4692208" y="872116"/>
+            <a:ext cx="4397363" cy="4919084"/>
           </a:xfrm>
           <a:prstGeom prst="rect">
             <a:avLst/>
           </a:prstGeom>
+          <a:noFill/>
+          <a:extLst>
+            <a:ext uri="{909E8E84-426E-40DD-AFC4-6F175D3DCCD1}">
+              <a14:hiddenFill xmlns:a14="http://schemas.microsoft.com/office/drawing/2010/main">
+                <a:solidFill>
+                  <a:srgbClr val="FFFFFF"/>
+                </a:solidFill>
+              </a14:hiddenFill>
+            </a:ext>
+          </a:extLst>
         </p:spPr>
       </p:pic>
       <p:sp>
         <p:nvSpPr>
-          <p:cNvPr id="8" name="TextBox 7">
+          <p:cNvPr id="10" name="TextBox 9">
             <a:extLst>
               <a:ext uri="{FF2B5EF4-FFF2-40B4-BE49-F238E27FC236}">
-                <a16:creationId xmlns:a16="http://schemas.microsoft.com/office/drawing/2014/main" id="{2A65F246-28F5-A3C8-D940-4D4E32D801D9}"/>
+                <a16:creationId xmlns:a16="http://schemas.microsoft.com/office/drawing/2014/main" xmlns="" id="{F18DC41E-0279-CBEA-6ED7-D98D5E4525C9}"/>
               </a:ext>
             </a:extLst>
           </p:cNvPr>
@@ -10799,8 +11618,8 @@
         </p:nvSpPr>
         <p:spPr>
           <a:xfrm>
-            <a:off x="449943" y="1600200"/>
-            <a:ext cx="3699218" cy="646331"/>
+            <a:off x="609600" y="4016828"/>
+            <a:ext cx="3410677" cy="369332"/>
           </a:xfrm>
           <a:prstGeom prst="rect">
             <a:avLst/>
@@ -10813,91 +11632,35 @@
           </a:bodyPr>
           <a:lstStyle/>
           <a:p>
-            <a:pPr marL="285750" indent="-285750">
-              <a:buFont typeface="Arial" panose="020B0604020202020204" pitchFamily="34" charset="0"/>
-              <a:buChar char="•"/>
-            </a:pPr>
-            <a:r>
-              <a:rPr lang="en-GR" dirty="0">
+            <a:r>
+              <a:rPr lang="x-none">
                 <a:solidFill>
                   <a:srgbClr val="00B050"/>
                 </a:solidFill>
               </a:rPr>
-              <a:t>Captures the “lump” in the middle</a:t>
-            </a:r>
-          </a:p>
-          <a:p>
-            <a:pPr marL="742950" lvl="1" indent="-285750">
-              <a:buFont typeface="Arial" panose="020B0604020202020204" pitchFamily="34" charset="0"/>
-              <a:buChar char="•"/>
-            </a:pPr>
-            <a:r>
-              <a:rPr lang="en-GR" dirty="0">
+              <a:t>Captures the “lump” in </a:t>
+            </a:r>
+            <a:r>
+              <a:rPr lang="x-none">
                 <a:solidFill>
                   <a:srgbClr val="00B050"/>
                 </a:solidFill>
               </a:rPr>
-              <a:t>Intraretinal F</a:t>
-            </a:r>
-            <a:r>
-              <a:rPr lang="en-GB" dirty="0">
+              <a:t>the </a:t>
+            </a:r>
+            <a:r>
+              <a:rPr lang="x-none" smtClean="0">
                 <a:solidFill>
                   <a:srgbClr val="00B050"/>
                 </a:solidFill>
               </a:rPr>
-              <a:t>l</a:t>
-            </a:r>
-            <a:r>
-              <a:rPr lang="en-GR" dirty="0">
-                <a:solidFill>
-                  <a:srgbClr val="00B050"/>
-                </a:solidFill>
-              </a:rPr>
-              <a:t>uid (IRF)</a:t>
-            </a:r>
-          </a:p>
-        </p:txBody>
-      </p:sp>
-      <p:sp>
-        <p:nvSpPr>
-          <p:cNvPr id="9" name="TextBox 8">
-            <a:extLst>
-              <a:ext uri="{FF2B5EF4-FFF2-40B4-BE49-F238E27FC236}">
-                <a16:creationId xmlns:a16="http://schemas.microsoft.com/office/drawing/2014/main" id="{4DA6F5A9-D1BA-7871-338F-AB21A580E37A}"/>
-              </a:ext>
-            </a:extLst>
-          </p:cNvPr>
-          <p:cNvSpPr txBox="1"/>
-          <p:nvPr/>
-        </p:nvSpPr>
-        <p:spPr>
-          <a:xfrm>
-            <a:off x="874097" y="2590800"/>
-            <a:ext cx="2850909" cy="369332"/>
-          </a:xfrm>
-          <a:prstGeom prst="rect">
-            <a:avLst/>
-          </a:prstGeom>
-          <a:noFill/>
-        </p:spPr>
-        <p:txBody>
-          <a:bodyPr wrap="none" rtlCol="0">
-            <a:spAutoFit/>
-          </a:bodyPr>
-          <a:lstStyle/>
-          <a:p>
-            <a:pPr marL="285750" indent="-285750">
-              <a:buFont typeface="Arial" panose="020B0604020202020204" pitchFamily="34" charset="0"/>
-              <a:buChar char="•"/>
-            </a:pPr>
-            <a:r>
-              <a:rPr lang="en-GR" dirty="0">
-                <a:solidFill>
-                  <a:srgbClr val="FF0000"/>
-                </a:solidFill>
-              </a:rPr>
-              <a:t>Also captures some noise</a:t>
-            </a:r>
+              <a:t>middle</a:t>
+            </a:r>
+            <a:endParaRPr lang="x-none">
+              <a:solidFill>
+                <a:srgbClr val="00B050"/>
+              </a:solidFill>
+            </a:endParaRPr>
           </a:p>
         </p:txBody>
       </p:sp>

</xml_diff>